<commit_message>
Update progress deck: all four R deliverables COMPLETE
R4 card flipped to green. Title updated to R1·R2·R3·R4.
New slide 6 shows R4 detail (4 cards). New slide 7 is the
closing slide: green completion strip + D1/D2/D3 optional
extensions with timing and pricing.

Co-Authored-By: Claude Sonnet 4.6 <noreply@anthropic.com>
</commit_message>
<xml_diff>
--- a/proposal/progress-report.pptx
+++ b/proposal/progress-report.pptx
@@ -11,6 +11,7 @@
     <p:sldId id="259" r:id="rId10"/>
     <p:sldId id="260" r:id="rId11"/>
     <p:sldId id="261" r:id="rId12"/>
+    <p:sldId id="262" r:id="rId13"/>
   </p:sldIdLst>
   <p:sldSz cx="12188952" cy="6858000" type="screen4x3"/>
   <p:notesSz cx="6858000" cy="9144000"/>
@@ -3234,7 +3235,7 @@
                 </a:solidFill>
               </a:rPr>
               <a:t>Sprint Review
-R1 · R2 · R3</a:t>
+R1 · R2 · R3 · R4</a:t>
             </a:r>
           </a:p>
         </p:txBody>
@@ -3268,8 +3269,8 @@
                   <a:srgbClr val="94A3B8"/>
                 </a:solidFill>
               </a:rPr>
-              <a:t>Three of four required deliverables complete.
-R4 architecture documentation in progress.</a:t>
+              <a:t>All four required deliverables complete.
+Engagement base scope delivered on schedule.</a:t>
             </a:r>
           </a:p>
         </p:txBody>
@@ -4388,7 +4389,7 @@
             <a:avLst/>
           </a:prstGeom>
           <a:solidFill>
-            <a:srgbClr val="2D1F07"/>
+            <a:srgbClr val="052E16"/>
           </a:solidFill>
           <a:ln>
             <a:noFill/>
@@ -4442,10 +4443,10 @@
             <a:r>
               <a:rPr sz="1000" b="1" i="0">
                 <a:solidFill>
-                  <a:srgbClr val="F59E0B"/>
-                </a:solidFill>
-              </a:rPr>
-              <a:t>IN PROGRESS</a:t>
+                  <a:srgbClr val="22C55E"/>
+                </a:solidFill>
+              </a:rPr>
+              <a:t>COMPLETE</a:t>
             </a:r>
           </a:p>
         </p:txBody>
@@ -4483,7 +4484,7 @@
                   <a:srgbClr val="CBD5E1"/>
                 </a:solidFill>
               </a:rPr>
-              <a:t>• HTML diagram</a:t>
+              <a:t>• HTML architecture diagram</a:t>
             </a:r>
           </a:p>
           <a:p>
@@ -4498,7 +4499,7 @@
                   <a:srgbClr val="CBD5E1"/>
                 </a:solidFill>
               </a:rPr>
-              <a:t>• Component map</a:t>
+              <a:t>• 15-endpoint API reference</a:t>
             </a:r>
           </a:p>
           <a:p>
@@ -4513,7 +4514,7 @@
                   <a:srgbClr val="CBD5E1"/>
                 </a:solidFill>
               </a:rPr>
-              <a:t>• API endpoint list</a:t>
+              <a:t>• Mock data layer docs</a:t>
             </a:r>
           </a:p>
           <a:p>
@@ -4528,7 +4529,7 @@
                   <a:srgbClr val="CBD5E1"/>
                 </a:solidFill>
               </a:rPr>
-              <a:t>• Meridian IT handoff</a:t>
+              <a:t>• IT handoff notes</a:t>
             </a:r>
           </a:p>
         </p:txBody>
@@ -7475,7 +7476,7 @@
             <a:avLst/>
           </a:prstGeom>
           <a:solidFill>
-            <a:srgbClr val="2D1F07"/>
+            <a:srgbClr val="052E16"/>
           </a:solidFill>
           <a:ln>
             <a:noFill/>
@@ -7529,10 +7530,10 @@
             <a:r>
               <a:rPr sz="1000" b="1" i="0">
                 <a:solidFill>
-                  <a:srgbClr val="F59E0B"/>
-                </a:solidFill>
-              </a:rPr>
-              <a:t>IN PROGRESS</a:t>
+                  <a:srgbClr val="22C55E"/>
+                </a:solidFill>
+              </a:rPr>
+              <a:t>COMPLETE</a:t>
             </a:r>
           </a:p>
         </p:txBody>
@@ -7546,7 +7547,7 @@
         <p:spPr>
           <a:xfrm>
             <a:off x="548640" y="822960"/>
-            <a:ext cx="10972800" cy="457200"/>
+            <a:ext cx="9144000" cy="457200"/>
           </a:xfrm>
           <a:prstGeom prst="rect">
             <a:avLst/>
@@ -7566,7 +7567,7 @@
                   <a:srgbClr val="38BDF8"/>
                 </a:solidFill>
               </a:rPr>
-              <a:t>R4 · Architecture Documentation  +  Next Steps</a:t>
+              <a:t>R4 · Architecture Documentation</a:t>
             </a:r>
           </a:p>
         </p:txBody>
@@ -7580,7 +7581,7 @@
         <p:spPr>
           <a:xfrm>
             <a:off x="548640" y="1234440"/>
-            <a:ext cx="8229600" cy="640080"/>
+            <a:ext cx="10058400" cy="914400"/>
           </a:xfrm>
           <a:prstGeom prst="rect">
             <a:avLst/>
@@ -7595,12 +7596,13 @@
           <a:p>
             <a:pPr algn="l"/>
             <a:r>
-              <a:rPr sz="3400" b="1" i="0">
+              <a:rPr sz="3200" b="1" i="0">
                 <a:solidFill>
                   <a:srgbClr val="F8FAFC"/>
                 </a:solidFill>
               </a:rPr>
-              <a:t>One deliverable remaining.</a:t>
+              <a:t>Full current-state docs
+delivered to Meridian IT.</a:t>
             </a:r>
           </a:p>
         </p:txBody>
@@ -7613,8 +7615,8 @@
         </p:nvSpPr>
         <p:spPr>
           <a:xfrm>
-            <a:off x="548640" y="2240280"/>
-            <a:ext cx="5394960" cy="3383280"/>
+            <a:off x="548640" y="2468880"/>
+            <a:ext cx="2651760" cy="2103120"/>
           </a:xfrm>
           <a:prstGeom prst="rect">
             <a:avLst/>
@@ -7658,8 +7660,8 @@
         </p:nvSpPr>
         <p:spPr>
           <a:xfrm>
-            <a:off x="731520" y="2377440"/>
-            <a:ext cx="5029200" cy="365760"/>
+            <a:off x="685800" y="2560320"/>
+            <a:ext cx="2377440" cy="411480"/>
           </a:xfrm>
           <a:prstGeom prst="rect">
             <a:avLst/>
@@ -7674,12 +7676,12 @@
           <a:p>
             <a:pPr algn="l"/>
             <a:r>
-              <a:rPr sz="1400" b="1" i="0">
+              <a:rPr sz="1300" b="1" i="0">
                 <a:solidFill>
                   <a:srgbClr val="38BDF8"/>
                 </a:solidFill>
               </a:rPr>
-              <a:t>R4 — What we're building</a:t>
+              <a:t>Tech stack overview</a:t>
             </a:r>
           </a:p>
         </p:txBody>
@@ -7692,77 +7694,28 @@
         </p:nvSpPr>
         <p:spPr>
           <a:xfrm>
-            <a:off x="731520" y="2834640"/>
-            <a:ext cx="5029200" cy="2560320"/>
-          </a:xfrm>
-          <a:prstGeom prst="rect">
-            <a:avLst/>
-          </a:prstGeom>
-          <a:noFill/>
-        </p:spPr>
-        <p:txBody>
-          <a:bodyPr wrap="square">
-            <a:spAutoFit/>
-          </a:bodyPr>
-          <a:lstStyle/>
-          <a:p>
-            <a:pPr>
-              <a:spcBef>
-                <a:spcPts val="700"/>
-              </a:spcBef>
-            </a:pPr>
-            <a:r>
-              <a:rPr sz="1300">
+            <a:off x="685800" y="2999232"/>
+            <a:ext cx="2377440" cy="1280160"/>
+          </a:xfrm>
+          <a:prstGeom prst="rect">
+            <a:avLst/>
+          </a:prstGeom>
+          <a:noFill/>
+        </p:spPr>
+        <p:txBody>
+          <a:bodyPr wrap="square">
+            <a:spAutoFit/>
+          </a:bodyPr>
+          <a:lstStyle/>
+          <a:p>
+            <a:pPr algn="l"/>
+            <a:r>
+              <a:rPr sz="1200" b="0" i="0">
                 <a:solidFill>
                   <a:srgbClr val="CBD5E1"/>
                 </a:solidFill>
               </a:rPr>
-              <a:t>→  HTML architecture diagram (component map + data flow)</a:t>
-            </a:r>
-          </a:p>
-          <a:p>
-            <a:pPr>
-              <a:spcBef>
-                <a:spcPts val="700"/>
-              </a:spcBef>
-            </a:pPr>
-            <a:r>
-              <a:rPr sz="1300">
-                <a:solidFill>
-                  <a:srgbClr val="CBD5E1"/>
-                </a:solidFill>
-              </a:rPr>
-              <a:t>→  API endpoint reference with request/response shapes</a:t>
-            </a:r>
-          </a:p>
-          <a:p>
-            <a:pPr>
-              <a:spcBef>
-                <a:spcPts val="700"/>
-              </a:spcBef>
-            </a:pPr>
-            <a:r>
-              <a:rPr sz="1300">
-                <a:solidFill>
-                  <a:srgbClr val="CBD5E1"/>
-                </a:solidFill>
-              </a:rPr>
-              <a:t>→  Mock-data layer documentation for Meridian IT</a:t>
-            </a:r>
-          </a:p>
-          <a:p>
-            <a:pPr>
-              <a:spcBef>
-                <a:spcPts val="700"/>
-              </a:spcBef>
-            </a:pPr>
-            <a:r>
-              <a:rPr sz="1300">
-                <a:solidFill>
-                  <a:srgbClr val="CBD5E1"/>
-                </a:solidFill>
-              </a:rPr>
-              <a:t>→  Handoff notes: how to extend the app post-engagement</a:t>
+              <a:t>Vue 3 + Vite / FastAPI + Pydantic / JSON mock data. Ports, run commands, CORS notes.</a:t>
             </a:r>
           </a:p>
         </p:txBody>
@@ -7775,8 +7728,8 @@
         </p:nvSpPr>
         <p:spPr>
           <a:xfrm>
-            <a:off x="6217920" y="2240280"/>
-            <a:ext cx="5394960" cy="3383280"/>
+            <a:off x="3355848" y="2468880"/>
+            <a:ext cx="2651760" cy="2103120"/>
           </a:xfrm>
           <a:prstGeom prst="rect">
             <a:avLst/>
@@ -7820,8 +7773,8 @@
         </p:nvSpPr>
         <p:spPr>
           <a:xfrm>
-            <a:off x="6400800" y="2377440"/>
-            <a:ext cx="5029200" cy="365760"/>
+            <a:off x="3493008" y="2560320"/>
+            <a:ext cx="2377440" cy="411480"/>
           </a:xfrm>
           <a:prstGeom prst="rect">
             <a:avLst/>
@@ -7836,110 +7789,1138 @@
           <a:p>
             <a:pPr algn="l"/>
             <a:r>
+              <a:rPr sz="1300" b="1" i="0">
+                <a:solidFill>
+                  <a:srgbClr val="38BDF8"/>
+                </a:solidFill>
+              </a:rPr>
+              <a:t>SVG component map</a:t>
+            </a:r>
+          </a:p>
+        </p:txBody>
+      </p:sp>
+      <p:sp>
+        <p:nvSpPr>
+          <p:cNvPr id="11" name="TextBox 10"/>
+          <p:cNvSpPr txBox="1"/>
+          <p:nvPr/>
+        </p:nvSpPr>
+        <p:spPr>
+          <a:xfrm>
+            <a:off x="3493008" y="2999232"/>
+            <a:ext cx="2377440" cy="1280160"/>
+          </a:xfrm>
+          <a:prstGeom prst="rect">
+            <a:avLst/>
+          </a:prstGeom>
+          <a:noFill/>
+        </p:spPr>
+        <p:txBody>
+          <a:bodyPr wrap="square">
+            <a:spAutoFit/>
+          </a:bodyPr>
+          <a:lstStyle/>
+          <a:p>
+            <a:pPr algn="l"/>
+            <a:r>
+              <a:rPr sz="1200" b="0" i="0">
+                <a:solidFill>
+                  <a:srgbClr val="CBD5E1"/>
+                </a:solidFill>
+              </a:rPr>
+              <a:t>Browser → api.js → FastAPI endpoints → mock data layer. Composables, data flow arrows, legend.</a:t>
+            </a:r>
+          </a:p>
+        </p:txBody>
+      </p:sp>
+      <p:sp>
+        <p:nvSpPr>
+          <p:cNvPr id="12" name="Rectangle 11"/>
+          <p:cNvSpPr/>
+          <p:nvPr/>
+        </p:nvSpPr>
+        <p:spPr>
+          <a:xfrm>
+            <a:off x="6163056" y="2468880"/>
+            <a:ext cx="2651760" cy="2103120"/>
+          </a:xfrm>
+          <a:prstGeom prst="rect">
+            <a:avLst/>
+          </a:prstGeom>
+          <a:solidFill>
+            <a:srgbClr val="1E293B"/>
+          </a:solidFill>
+          <a:ln w="9525">
+            <a:solidFill>
+              <a:srgbClr val="334155"/>
+            </a:solidFill>
+          </a:ln>
+        </p:spPr>
+        <p:style>
+          <a:lnRef idx="1">
+            <a:schemeClr val="accent1"/>
+          </a:lnRef>
+          <a:fillRef idx="3">
+            <a:schemeClr val="accent1"/>
+          </a:fillRef>
+          <a:effectRef idx="2">
+            <a:schemeClr val="accent1"/>
+          </a:effectRef>
+          <a:fontRef idx="minor">
+            <a:schemeClr val="lt1"/>
+          </a:fontRef>
+        </p:style>
+        <p:txBody>
+          <a:bodyPr rtlCol="0" anchor="ctr"/>
+          <a:lstStyle/>
+          <a:p>
+            <a:pPr algn="ctr"/>
+          </a:p>
+        </p:txBody>
+      </p:sp>
+      <p:sp>
+        <p:nvSpPr>
+          <p:cNvPr id="13" name="TextBox 12"/>
+          <p:cNvSpPr txBox="1"/>
+          <p:nvPr/>
+        </p:nvSpPr>
+        <p:spPr>
+          <a:xfrm>
+            <a:off x="6300216" y="2560320"/>
+            <a:ext cx="2377440" cy="411480"/>
+          </a:xfrm>
+          <a:prstGeom prst="rect">
+            <a:avLst/>
+          </a:prstGeom>
+          <a:noFill/>
+        </p:spPr>
+        <p:txBody>
+          <a:bodyPr wrap="square">
+            <a:spAutoFit/>
+          </a:bodyPr>
+          <a:lstStyle/>
+          <a:p>
+            <a:pPr algn="l"/>
+            <a:r>
+              <a:rPr sz="1300" b="1" i="0">
+                <a:solidFill>
+                  <a:srgbClr val="38BDF8"/>
+                </a:solidFill>
+              </a:rPr>
+              <a:t>API endpoint reference</a:t>
+            </a:r>
+          </a:p>
+        </p:txBody>
+      </p:sp>
+      <p:sp>
+        <p:nvSpPr>
+          <p:cNvPr id="14" name="TextBox 13"/>
+          <p:cNvSpPr txBox="1"/>
+          <p:nvPr/>
+        </p:nvSpPr>
+        <p:spPr>
+          <a:xfrm>
+            <a:off x="6300216" y="2999232"/>
+            <a:ext cx="2377440" cy="1280160"/>
+          </a:xfrm>
+          <a:prstGeom prst="rect">
+            <a:avLst/>
+          </a:prstGeom>
+          <a:noFill/>
+        </p:spPr>
+        <p:txBody>
+          <a:bodyPr wrap="square">
+            <a:spAutoFit/>
+          </a:bodyPr>
+          <a:lstStyle/>
+          <a:p>
+            <a:pPr algn="l"/>
+            <a:r>
+              <a:rPr sz="1200" b="0" i="0">
+                <a:solidFill>
+                  <a:srgbClr val="CBD5E1"/>
+                </a:solidFill>
+              </a:rPr>
+              <a:t>15 endpoints: method, path, all query params, JSON response shape. Restocking ★ flagged as new.</a:t>
+            </a:r>
+          </a:p>
+        </p:txBody>
+      </p:sp>
+      <p:sp>
+        <p:nvSpPr>
+          <p:cNvPr id="15" name="Rectangle 14"/>
+          <p:cNvSpPr/>
+          <p:nvPr/>
+        </p:nvSpPr>
+        <p:spPr>
+          <a:xfrm>
+            <a:off x="8970264" y="2468880"/>
+            <a:ext cx="2651760" cy="2103120"/>
+          </a:xfrm>
+          <a:prstGeom prst="rect">
+            <a:avLst/>
+          </a:prstGeom>
+          <a:solidFill>
+            <a:srgbClr val="1E293B"/>
+          </a:solidFill>
+          <a:ln w="9525">
+            <a:solidFill>
+              <a:srgbClr val="334155"/>
+            </a:solidFill>
+          </a:ln>
+        </p:spPr>
+        <p:style>
+          <a:lnRef idx="1">
+            <a:schemeClr val="accent1"/>
+          </a:lnRef>
+          <a:fillRef idx="3">
+            <a:schemeClr val="accent1"/>
+          </a:fillRef>
+          <a:effectRef idx="2">
+            <a:schemeClr val="accent1"/>
+          </a:effectRef>
+          <a:fontRef idx="minor">
+            <a:schemeClr val="lt1"/>
+          </a:fontRef>
+        </p:style>
+        <p:txBody>
+          <a:bodyPr rtlCol="0" anchor="ctr"/>
+          <a:lstStyle/>
+          <a:p>
+            <a:pPr algn="ctr"/>
+          </a:p>
+        </p:txBody>
+      </p:sp>
+      <p:sp>
+        <p:nvSpPr>
+          <p:cNvPr id="16" name="TextBox 15"/>
+          <p:cNvSpPr txBox="1"/>
+          <p:nvPr/>
+        </p:nvSpPr>
+        <p:spPr>
+          <a:xfrm>
+            <a:off x="9107424" y="2560320"/>
+            <a:ext cx="2377440" cy="411480"/>
+          </a:xfrm>
+          <a:prstGeom prst="rect">
+            <a:avLst/>
+          </a:prstGeom>
+          <a:noFill/>
+        </p:spPr>
+        <p:txBody>
+          <a:bodyPr wrap="square">
+            <a:spAutoFit/>
+          </a:bodyPr>
+          <a:lstStyle/>
+          <a:p>
+            <a:pPr algn="l"/>
+            <a:r>
+              <a:rPr sz="1300" b="1" i="0">
+                <a:solidFill>
+                  <a:srgbClr val="38BDF8"/>
+                </a:solidFill>
+              </a:rPr>
+              <a:t>IT handoff notes</a:t>
+            </a:r>
+          </a:p>
+        </p:txBody>
+      </p:sp>
+      <p:sp>
+        <p:nvSpPr>
+          <p:cNvPr id="17" name="TextBox 16"/>
+          <p:cNvSpPr txBox="1"/>
+          <p:nvPr/>
+        </p:nvSpPr>
+        <p:spPr>
+          <a:xfrm>
+            <a:off x="9107424" y="2999232"/>
+            <a:ext cx="2377440" cy="1280160"/>
+          </a:xfrm>
+          <a:prstGeom prst="rect">
+            <a:avLst/>
+          </a:prstGeom>
+          <a:noFill/>
+        </p:spPr>
+        <p:txBody>
+          <a:bodyPr wrap="square">
+            <a:spAutoFit/>
+          </a:bodyPr>
+          <a:lstStyle/>
+          <a:p>
+            <a:pPr algn="l"/>
+            <a:r>
+              <a:rPr sz="1200" b="0" i="0">
+                <a:solidFill>
+                  <a:srgbClr val="CBD5E1"/>
+                </a:solidFill>
+              </a:rPr>
+              <a:t>How to add endpoints, add views, replace JSON with a real DB, run the Playwright suite.</a:t>
+            </a:r>
+          </a:p>
+        </p:txBody>
+      </p:sp>
+    </p:spTree>
+  </p:cSld>
+  <p:clrMapOvr>
+    <a:masterClrMapping/>
+  </p:clrMapOvr>
+</p:sld>
+</file>
+
+<file path=ppt/slides/slide7.xml><?xml version="1.0" encoding="utf-8"?>
+<p:sld xmlns:a="http://schemas.openxmlformats.org/drawingml/2006/main" xmlns:p="http://schemas.openxmlformats.org/presentationml/2006/main" xmlns:r="http://schemas.openxmlformats.org/officeDocument/2006/relationships">
+  <p:cSld>
+    <p:bg>
+      <p:bgPr>
+        <a:solidFill>
+          <a:srgbClr val="0F172A"/>
+        </a:solidFill>
+        <a:effectLst/>
+      </p:bgPr>
+    </p:bg>
+    <p:spTree>
+      <p:nvGrpSpPr>
+        <p:cNvPr id="1" name=""/>
+        <p:cNvGrpSpPr/>
+        <p:nvPr/>
+      </p:nvGrpSpPr>
+      <p:grpSpPr/>
+      <p:sp>
+        <p:nvSpPr>
+          <p:cNvPr id="2" name="TextBox 1"/>
+          <p:cNvSpPr txBox="1"/>
+          <p:nvPr/>
+        </p:nvSpPr>
+        <p:spPr>
+          <a:xfrm>
+            <a:off x="548640" y="457200"/>
+            <a:ext cx="10972800" cy="365760"/>
+          </a:xfrm>
+          <a:prstGeom prst="rect">
+            <a:avLst/>
+          </a:prstGeom>
+          <a:noFill/>
+        </p:spPr>
+        <p:txBody>
+          <a:bodyPr wrap="square">
+            <a:spAutoFit/>
+          </a:bodyPr>
+          <a:lstStyle/>
+          <a:p>
+            <a:pPr algn="l"/>
+            <a:r>
+              <a:rPr sz="1100" b="1" i="0">
+                <a:solidFill>
+                  <a:srgbClr val="475569"/>
+                </a:solidFill>
+              </a:rPr>
+              <a:t>ACCENTURE&amp;CT CONSULTING  ·  MERIDIAN COMPONENTS</a:t>
+            </a:r>
+          </a:p>
+        </p:txBody>
+      </p:sp>
+      <p:cxnSp>
+        <p:nvCxnSpPr>
+          <p:cNvPr id="3" name="Connector 2"/>
+          <p:cNvCxnSpPr/>
+          <p:nvPr/>
+        </p:nvCxnSpPr>
+        <p:spPr>
+          <a:xfrm>
+            <a:off x="548640" y="914400"/>
+            <a:ext cx="1097280" cy="0"/>
+          </a:xfrm>
+          <a:prstGeom prst="line">
+            <a:avLst/>
+          </a:prstGeom>
+          <a:ln w="25400">
+            <a:solidFill>
+              <a:srgbClr val="38BDF8"/>
+            </a:solidFill>
+          </a:ln>
+        </p:spPr>
+        <p:style>
+          <a:lnRef idx="2">
+            <a:schemeClr val="accent1"/>
+          </a:lnRef>
+          <a:fillRef idx="0">
+            <a:schemeClr val="accent1"/>
+          </a:fillRef>
+          <a:effectRef idx="1">
+            <a:schemeClr val="accent1"/>
+          </a:effectRef>
+          <a:fontRef idx="minor">
+            <a:schemeClr val="tx1"/>
+          </a:fontRef>
+        </p:style>
+      </p:cxnSp>
+      <p:sp>
+        <p:nvSpPr>
+          <p:cNvPr id="4" name="TextBox 3"/>
+          <p:cNvSpPr txBox="1"/>
+          <p:nvPr/>
+        </p:nvSpPr>
+        <p:spPr>
+          <a:xfrm>
+            <a:off x="548640" y="1005840"/>
+            <a:ext cx="9144000" cy="365760"/>
+          </a:xfrm>
+          <a:prstGeom prst="rect">
+            <a:avLst/>
+          </a:prstGeom>
+          <a:noFill/>
+        </p:spPr>
+        <p:txBody>
+          <a:bodyPr wrap="square">
+            <a:spAutoFit/>
+          </a:bodyPr>
+          <a:lstStyle/>
+          <a:p>
+            <a:pPr algn="l"/>
+            <a:r>
+              <a:rPr sz="1100" b="1" i="0">
+                <a:solidFill>
+                  <a:srgbClr val="38BDF8"/>
+                </a:solidFill>
+              </a:rPr>
+              <a:t>BASE ENGAGEMENT · COMPLETE</a:t>
+            </a:r>
+          </a:p>
+        </p:txBody>
+      </p:sp>
+      <p:sp>
+        <p:nvSpPr>
+          <p:cNvPr id="5" name="TextBox 4"/>
+          <p:cNvSpPr txBox="1"/>
+          <p:nvPr/>
+        </p:nvSpPr>
+        <p:spPr>
+          <a:xfrm>
+            <a:off x="548640" y="1417320"/>
+            <a:ext cx="7315200" cy="1463040"/>
+          </a:xfrm>
+          <a:prstGeom prst="rect">
+            <a:avLst/>
+          </a:prstGeom>
+          <a:noFill/>
+        </p:spPr>
+        <p:txBody>
+          <a:bodyPr wrap="square">
+            <a:spAutoFit/>
+          </a:bodyPr>
+          <a:lstStyle/>
+          <a:p>
+            <a:pPr algn="l"/>
+            <a:r>
+              <a:rPr sz="4400" b="1" i="0">
+                <a:solidFill>
+                  <a:srgbClr val="F8FAFC"/>
+                </a:solidFill>
+              </a:rPr>
+              <a:t>R1 · R2 · R3 · R4
+All delivered.</a:t>
+            </a:r>
+          </a:p>
+        </p:txBody>
+      </p:sp>
+      <p:sp>
+        <p:nvSpPr>
+          <p:cNvPr id="6" name="Rectangle 5"/>
+          <p:cNvSpPr/>
+          <p:nvPr/>
+        </p:nvSpPr>
+        <p:spPr>
+          <a:xfrm>
+            <a:off x="548640" y="3017520"/>
+            <a:ext cx="11064240" cy="548640"/>
+          </a:xfrm>
+          <a:prstGeom prst="rect">
+            <a:avLst/>
+          </a:prstGeom>
+          <a:solidFill>
+            <a:srgbClr val="052E16"/>
+          </a:solidFill>
+          <a:ln w="9525">
+            <a:solidFill>
+              <a:srgbClr val="166534"/>
+            </a:solidFill>
+          </a:ln>
+        </p:spPr>
+        <p:style>
+          <a:lnRef idx="1">
+            <a:schemeClr val="accent1"/>
+          </a:lnRef>
+          <a:fillRef idx="3">
+            <a:schemeClr val="accent1"/>
+          </a:fillRef>
+          <a:effectRef idx="2">
+            <a:schemeClr val="accent1"/>
+          </a:effectRef>
+          <a:fontRef idx="minor">
+            <a:schemeClr val="lt1"/>
+          </a:fontRef>
+        </p:style>
+        <p:txBody>
+          <a:bodyPr rtlCol="0" anchor="ctr"/>
+          <a:lstStyle/>
+          <a:p>
+            <a:pPr algn="ctr"/>
+          </a:p>
+        </p:txBody>
+      </p:sp>
+      <p:sp>
+        <p:nvSpPr>
+          <p:cNvPr id="7" name="TextBox 6"/>
+          <p:cNvSpPr txBox="1"/>
+          <p:nvPr/>
+        </p:nvSpPr>
+        <p:spPr>
+          <a:xfrm>
+            <a:off x="822960" y="3090672"/>
+            <a:ext cx="2468880" cy="384048"/>
+          </a:xfrm>
+          <a:prstGeom prst="rect">
+            <a:avLst/>
+          </a:prstGeom>
+          <a:noFill/>
+        </p:spPr>
+        <p:txBody>
+          <a:bodyPr wrap="square">
+            <a:spAutoFit/>
+          </a:bodyPr>
+          <a:lstStyle/>
+          <a:p>
+            <a:pPr algn="l"/>
+            <a:r>
+              <a:rPr sz="1300" b="1" i="0">
+                <a:solidFill>
+                  <a:srgbClr val="22C55E"/>
+                </a:solidFill>
+              </a:rPr>
+              <a:t>✓  R1  Reports fixed</a:t>
+            </a:r>
+          </a:p>
+        </p:txBody>
+      </p:sp>
+      <p:sp>
+        <p:nvSpPr>
+          <p:cNvPr id="8" name="TextBox 7"/>
+          <p:cNvSpPr txBox="1"/>
+          <p:nvPr/>
+        </p:nvSpPr>
+        <p:spPr>
+          <a:xfrm>
+            <a:off x="3566160" y="3090672"/>
+            <a:ext cx="2468880" cy="384048"/>
+          </a:xfrm>
+          <a:prstGeom prst="rect">
+            <a:avLst/>
+          </a:prstGeom>
+          <a:noFill/>
+        </p:spPr>
+        <p:txBody>
+          <a:bodyPr wrap="square">
+            <a:spAutoFit/>
+          </a:bodyPr>
+          <a:lstStyle/>
+          <a:p>
+            <a:pPr algn="l"/>
+            <a:r>
+              <a:rPr sz="1300" b="1" i="0">
+                <a:solidFill>
+                  <a:srgbClr val="22C55E"/>
+                </a:solidFill>
+              </a:rPr>
+              <a:t>✓  R2  Restocking view</a:t>
+            </a:r>
+          </a:p>
+        </p:txBody>
+      </p:sp>
+      <p:sp>
+        <p:nvSpPr>
+          <p:cNvPr id="9" name="TextBox 8"/>
+          <p:cNvSpPr txBox="1"/>
+          <p:nvPr/>
+        </p:nvSpPr>
+        <p:spPr>
+          <a:xfrm>
+            <a:off x="6309360" y="3090672"/>
+            <a:ext cx="2468880" cy="384048"/>
+          </a:xfrm>
+          <a:prstGeom prst="rect">
+            <a:avLst/>
+          </a:prstGeom>
+          <a:noFill/>
+        </p:spPr>
+        <p:txBody>
+          <a:bodyPr wrap="square">
+            <a:spAutoFit/>
+          </a:bodyPr>
+          <a:lstStyle/>
+          <a:p>
+            <a:pPr algn="l"/>
+            <a:r>
+              <a:rPr sz="1300" b="1" i="0">
+                <a:solidFill>
+                  <a:srgbClr val="22C55E"/>
+                </a:solidFill>
+              </a:rPr>
+              <a:t>✓  R3  59/59 tests</a:t>
+            </a:r>
+          </a:p>
+        </p:txBody>
+      </p:sp>
+      <p:sp>
+        <p:nvSpPr>
+          <p:cNvPr id="10" name="TextBox 9"/>
+          <p:cNvSpPr txBox="1"/>
+          <p:nvPr/>
+        </p:nvSpPr>
+        <p:spPr>
+          <a:xfrm>
+            <a:off x="9052560" y="3090672"/>
+            <a:ext cx="2468880" cy="384048"/>
+          </a:xfrm>
+          <a:prstGeom prst="rect">
+            <a:avLst/>
+          </a:prstGeom>
+          <a:noFill/>
+        </p:spPr>
+        <p:txBody>
+          <a:bodyPr wrap="square">
+            <a:spAutoFit/>
+          </a:bodyPr>
+          <a:lstStyle/>
+          <a:p>
+            <a:pPr algn="l"/>
+            <a:r>
+              <a:rPr sz="1300" b="1" i="0">
+                <a:solidFill>
+                  <a:srgbClr val="22C55E"/>
+                </a:solidFill>
+              </a:rPr>
+              <a:t>✓  R4  Architecture docs</a:t>
+            </a:r>
+          </a:p>
+        </p:txBody>
+      </p:sp>
+      <p:sp>
+        <p:nvSpPr>
+          <p:cNvPr id="11" name="Rectangle 10"/>
+          <p:cNvSpPr/>
+          <p:nvPr/>
+        </p:nvSpPr>
+        <p:spPr>
+          <a:xfrm>
+            <a:off x="548640" y="3794760"/>
+            <a:ext cx="11064240" cy="2423160"/>
+          </a:xfrm>
+          <a:prstGeom prst="rect">
+            <a:avLst/>
+          </a:prstGeom>
+          <a:solidFill>
+            <a:srgbClr val="1E293B"/>
+          </a:solidFill>
+          <a:ln w="9525">
+            <a:solidFill>
+              <a:srgbClr val="334155"/>
+            </a:solidFill>
+          </a:ln>
+        </p:spPr>
+        <p:style>
+          <a:lnRef idx="1">
+            <a:schemeClr val="accent1"/>
+          </a:lnRef>
+          <a:fillRef idx="3">
+            <a:schemeClr val="accent1"/>
+          </a:fillRef>
+          <a:effectRef idx="2">
+            <a:schemeClr val="accent1"/>
+          </a:effectRef>
+          <a:fontRef idx="minor">
+            <a:schemeClr val="lt1"/>
+          </a:fontRef>
+        </p:style>
+        <p:txBody>
+          <a:bodyPr rtlCol="0" anchor="ctr"/>
+          <a:lstStyle/>
+          <a:p>
+            <a:pPr algn="ctr"/>
+          </a:p>
+        </p:txBody>
+      </p:sp>
+      <p:sp>
+        <p:nvSpPr>
+          <p:cNvPr id="12" name="TextBox 11"/>
+          <p:cNvSpPr txBox="1"/>
+          <p:nvPr/>
+        </p:nvSpPr>
+        <p:spPr>
+          <a:xfrm>
+            <a:off x="731520" y="3931920"/>
+            <a:ext cx="10058400" cy="365760"/>
+          </a:xfrm>
+          <a:prstGeom prst="rect">
+            <a:avLst/>
+          </a:prstGeom>
+          <a:noFill/>
+        </p:spPr>
+        <p:txBody>
+          <a:bodyPr wrap="square">
+            <a:spAutoFit/>
+          </a:bodyPr>
+          <a:lstStyle/>
+          <a:p>
+            <a:pPr algn="l"/>
+            <a:r>
               <a:rPr sz="1400" b="1" i="0">
                 <a:solidFill>
                   <a:srgbClr val="38BDF8"/>
                 </a:solidFill>
               </a:rPr>
-              <a:t>Remaining work + optional</a:t>
-            </a:r>
-          </a:p>
-        </p:txBody>
-      </p:sp>
-      <p:sp>
-        <p:nvSpPr>
-          <p:cNvPr id="11" name="TextBox 10"/>
-          <p:cNvSpPr txBox="1"/>
-          <p:nvPr/>
-        </p:nvSpPr>
-        <p:spPr>
-          <a:xfrm>
-            <a:off x="6400800" y="2834640"/>
-            <a:ext cx="5029200" cy="2560320"/>
-          </a:xfrm>
-          <a:prstGeom prst="rect">
-            <a:avLst/>
-          </a:prstGeom>
-          <a:noFill/>
-        </p:spPr>
-        <p:txBody>
-          <a:bodyPr wrap="square">
-            <a:spAutoFit/>
-          </a:bodyPr>
-          <a:lstStyle/>
-          <a:p>
-            <a:pPr>
-              <a:spcBef>
-                <a:spcPts val="700"/>
-              </a:spcBef>
-            </a:pPr>
-            <a:r>
-              <a:rPr sz="1300">
+              <a:t>Optional extensions — available now</a:t>
+            </a:r>
+          </a:p>
+        </p:txBody>
+      </p:sp>
+      <p:sp>
+        <p:nvSpPr>
+          <p:cNvPr id="13" name="TextBox 12"/>
+          <p:cNvSpPr txBox="1"/>
+          <p:nvPr/>
+        </p:nvSpPr>
+        <p:spPr>
+          <a:xfrm>
+            <a:off x="731520" y="4407408"/>
+            <a:ext cx="3291840" cy="292608"/>
+          </a:xfrm>
+          <a:prstGeom prst="rect">
+            <a:avLst/>
+          </a:prstGeom>
+          <a:noFill/>
+        </p:spPr>
+        <p:txBody>
+          <a:bodyPr wrap="square">
+            <a:spAutoFit/>
+          </a:bodyPr>
+          <a:lstStyle/>
+          <a:p>
+            <a:pPr algn="l"/>
+            <a:r>
+              <a:rPr sz="1300" b="1" i="0">
+                <a:solidFill>
+                  <a:srgbClr val="F8FAFC"/>
+                </a:solidFill>
+              </a:rPr>
+              <a:t>D1 · UI Refresh</a:t>
+            </a:r>
+          </a:p>
+        </p:txBody>
+      </p:sp>
+      <p:sp>
+        <p:nvSpPr>
+          <p:cNvPr id="14" name="TextBox 13"/>
+          <p:cNvSpPr txBox="1"/>
+          <p:nvPr/>
+        </p:nvSpPr>
+        <p:spPr>
+          <a:xfrm>
+            <a:off x="731520" y="4709160"/>
+            <a:ext cx="1645920" cy="256032"/>
+          </a:xfrm>
+          <a:prstGeom prst="rect">
+            <a:avLst/>
+          </a:prstGeom>
+          <a:noFill/>
+        </p:spPr>
+        <p:txBody>
+          <a:bodyPr wrap="square">
+            <a:spAutoFit/>
+          </a:bodyPr>
+          <a:lstStyle/>
+          <a:p>
+            <a:pPr algn="l"/>
+            <a:r>
+              <a:rPr sz="1100" b="0" i="0">
+                <a:solidFill>
+                  <a:srgbClr val="94A3B8"/>
+                </a:solidFill>
+              </a:rPr>
+              <a:t>Weeks 11–12</a:t>
+            </a:r>
+          </a:p>
+        </p:txBody>
+      </p:sp>
+      <p:sp>
+        <p:nvSpPr>
+          <p:cNvPr id="15" name="TextBox 14"/>
+          <p:cNvSpPr txBox="1"/>
+          <p:nvPr/>
+        </p:nvSpPr>
+        <p:spPr>
+          <a:xfrm>
+            <a:off x="2468880" y="4709160"/>
+            <a:ext cx="1463040" cy="256032"/>
+          </a:xfrm>
+          <a:prstGeom prst="rect">
+            <a:avLst/>
+          </a:prstGeom>
+          <a:noFill/>
+        </p:spPr>
+        <p:txBody>
+          <a:bodyPr wrap="square">
+            <a:spAutoFit/>
+          </a:bodyPr>
+          <a:lstStyle/>
+          <a:p>
+            <a:pPr algn="l"/>
+            <a:r>
+              <a:rPr sz="1100" b="1" i="0">
+                <a:solidFill>
+                  <a:srgbClr val="38BDF8"/>
+                </a:solidFill>
+              </a:rPr>
+              <a:t>$12,000</a:t>
+            </a:r>
+          </a:p>
+        </p:txBody>
+      </p:sp>
+      <p:sp>
+        <p:nvSpPr>
+          <p:cNvPr id="16" name="TextBox 15"/>
+          <p:cNvSpPr txBox="1"/>
+          <p:nvPr/>
+        </p:nvSpPr>
+        <p:spPr>
+          <a:xfrm>
+            <a:off x="731520" y="5010912"/>
+            <a:ext cx="3291840" cy="502920"/>
+          </a:xfrm>
+          <a:prstGeom prst="rect">
+            <a:avLst/>
+          </a:prstGeom>
+          <a:noFill/>
+        </p:spPr>
+        <p:txBody>
+          <a:bodyPr wrap="square">
+            <a:spAutoFit/>
+          </a:bodyPr>
+          <a:lstStyle/>
+          <a:p>
+            <a:pPr algn="l"/>
+            <a:r>
+              <a:rPr sz="1100" b="0" i="0">
                 <a:solidFill>
                   <a:srgbClr val="CBD5E1"/>
                 </a:solidFill>
               </a:rPr>
-              <a:t>→  R4: Architecture HTML + handoff doc  (next)</a:t>
-            </a:r>
-          </a:p>
-          <a:p>
-            <a:pPr>
-              <a:spcBef>
-                <a:spcPts val="700"/>
-              </a:spcBef>
-            </a:pPr>
-            <a:r>
-              <a:rPr sz="1300">
+              <a:t>Visual modernisation, spacing, colour system, mobile-responsive layout.</a:t>
+            </a:r>
+          </a:p>
+        </p:txBody>
+      </p:sp>
+      <p:sp>
+        <p:nvSpPr>
+          <p:cNvPr id="17" name="TextBox 16"/>
+          <p:cNvSpPr txBox="1"/>
+          <p:nvPr/>
+        </p:nvSpPr>
+        <p:spPr>
+          <a:xfrm>
+            <a:off x="4389120" y="4407408"/>
+            <a:ext cx="3291840" cy="292608"/>
+          </a:xfrm>
+          <a:prstGeom prst="rect">
+            <a:avLst/>
+          </a:prstGeom>
+          <a:noFill/>
+        </p:spPr>
+        <p:txBody>
+          <a:bodyPr wrap="square">
+            <a:spAutoFit/>
+          </a:bodyPr>
+          <a:lstStyle/>
+          <a:p>
+            <a:pPr algn="l"/>
+            <a:r>
+              <a:rPr sz="1300" b="1" i="0">
+                <a:solidFill>
+                  <a:srgbClr val="F8FAFC"/>
+                </a:solidFill>
+              </a:rPr>
+              <a:t>D2 · i18n Expansion</a:t>
+            </a:r>
+          </a:p>
+        </p:txBody>
+      </p:sp>
+      <p:sp>
+        <p:nvSpPr>
+          <p:cNvPr id="18" name="TextBox 17"/>
+          <p:cNvSpPr txBox="1"/>
+          <p:nvPr/>
+        </p:nvSpPr>
+        <p:spPr>
+          <a:xfrm>
+            <a:off x="4389120" y="4709160"/>
+            <a:ext cx="1645920" cy="256032"/>
+          </a:xfrm>
+          <a:prstGeom prst="rect">
+            <a:avLst/>
+          </a:prstGeom>
+          <a:noFill/>
+        </p:spPr>
+        <p:txBody>
+          <a:bodyPr wrap="square">
+            <a:spAutoFit/>
+          </a:bodyPr>
+          <a:lstStyle/>
+          <a:p>
+            <a:pPr algn="l"/>
+            <a:r>
+              <a:rPr sz="1100" b="0" i="0">
+                <a:solidFill>
+                  <a:srgbClr val="94A3B8"/>
+                </a:solidFill>
+              </a:rPr>
+              <a:t>Week 13</a:t>
+            </a:r>
+          </a:p>
+        </p:txBody>
+      </p:sp>
+      <p:sp>
+        <p:nvSpPr>
+          <p:cNvPr id="19" name="TextBox 18"/>
+          <p:cNvSpPr txBox="1"/>
+          <p:nvPr/>
+        </p:nvSpPr>
+        <p:spPr>
+          <a:xfrm>
+            <a:off x="6126479" y="4709160"/>
+            <a:ext cx="1463040" cy="256032"/>
+          </a:xfrm>
+          <a:prstGeom prst="rect">
+            <a:avLst/>
+          </a:prstGeom>
+          <a:noFill/>
+        </p:spPr>
+        <p:txBody>
+          <a:bodyPr wrap="square">
+            <a:spAutoFit/>
+          </a:bodyPr>
+          <a:lstStyle/>
+          <a:p>
+            <a:pPr algn="l"/>
+            <a:r>
+              <a:rPr sz="1100" b="1" i="0">
+                <a:solidFill>
+                  <a:srgbClr val="38BDF8"/>
+                </a:solidFill>
+              </a:rPr>
+              <a:t>$8,000</a:t>
+            </a:r>
+          </a:p>
+        </p:txBody>
+      </p:sp>
+      <p:sp>
+        <p:nvSpPr>
+          <p:cNvPr id="20" name="TextBox 19"/>
+          <p:cNvSpPr txBox="1"/>
+          <p:nvPr/>
+        </p:nvSpPr>
+        <p:spPr>
+          <a:xfrm>
+            <a:off x="4389120" y="5010912"/>
+            <a:ext cx="3291840" cy="502920"/>
+          </a:xfrm>
+          <a:prstGeom prst="rect">
+            <a:avLst/>
+          </a:prstGeom>
+          <a:noFill/>
+        </p:spPr>
+        <p:txBody>
+          <a:bodyPr wrap="square">
+            <a:spAutoFit/>
+          </a:bodyPr>
+          <a:lstStyle/>
+          <a:p>
+            <a:pPr algn="l"/>
+            <a:r>
+              <a:rPr sz="1100" b="0" i="0">
                 <a:solidFill>
                   <a:srgbClr val="CBD5E1"/>
                 </a:solidFill>
               </a:rPr>
-              <a:t>→  D1: UI refresh  (optional, weeks 11–12)</a:t>
-            </a:r>
-          </a:p>
-          <a:p>
-            <a:pPr>
-              <a:spcBef>
-                <a:spcPts val="700"/>
-              </a:spcBef>
-            </a:pPr>
-            <a:r>
-              <a:rPr sz="1300">
+              <a:t>Additional languages beyond EN/JA. Locale-aware number/date formatting.</a:t>
+            </a:r>
+          </a:p>
+        </p:txBody>
+      </p:sp>
+      <p:sp>
+        <p:nvSpPr>
+          <p:cNvPr id="21" name="TextBox 20"/>
+          <p:cNvSpPr txBox="1"/>
+          <p:nvPr/>
+        </p:nvSpPr>
+        <p:spPr>
+          <a:xfrm>
+            <a:off x="8046720" y="4407408"/>
+            <a:ext cx="3291840" cy="292608"/>
+          </a:xfrm>
+          <a:prstGeom prst="rect">
+            <a:avLst/>
+          </a:prstGeom>
+          <a:noFill/>
+        </p:spPr>
+        <p:txBody>
+          <a:bodyPr wrap="square">
+            <a:spAutoFit/>
+          </a:bodyPr>
+          <a:lstStyle/>
+          <a:p>
+            <a:pPr algn="l"/>
+            <a:r>
+              <a:rPr sz="1300" b="1" i="0">
+                <a:solidFill>
+                  <a:srgbClr val="F8FAFC"/>
+                </a:solidFill>
+              </a:rPr>
+              <a:t>D3 · Dark Mode</a:t>
+            </a:r>
+          </a:p>
+        </p:txBody>
+      </p:sp>
+      <p:sp>
+        <p:nvSpPr>
+          <p:cNvPr id="22" name="TextBox 21"/>
+          <p:cNvSpPr txBox="1"/>
+          <p:nvPr/>
+        </p:nvSpPr>
+        <p:spPr>
+          <a:xfrm>
+            <a:off x="8046720" y="4709160"/>
+            <a:ext cx="1645920" cy="256032"/>
+          </a:xfrm>
+          <a:prstGeom prst="rect">
+            <a:avLst/>
+          </a:prstGeom>
+          <a:noFill/>
+        </p:spPr>
+        <p:txBody>
+          <a:bodyPr wrap="square">
+            <a:spAutoFit/>
+          </a:bodyPr>
+          <a:lstStyle/>
+          <a:p>
+            <a:pPr algn="l"/>
+            <a:r>
+              <a:rPr sz="1100" b="0" i="0">
+                <a:solidFill>
+                  <a:srgbClr val="94A3B8"/>
+                </a:solidFill>
+              </a:rPr>
+              <a:t>Week 13</a:t>
+            </a:r>
+          </a:p>
+        </p:txBody>
+      </p:sp>
+      <p:sp>
+        <p:nvSpPr>
+          <p:cNvPr id="23" name="TextBox 22"/>
+          <p:cNvSpPr txBox="1"/>
+          <p:nvPr/>
+        </p:nvSpPr>
+        <p:spPr>
+          <a:xfrm>
+            <a:off x="9784080" y="4709160"/>
+            <a:ext cx="1463040" cy="256032"/>
+          </a:xfrm>
+          <a:prstGeom prst="rect">
+            <a:avLst/>
+          </a:prstGeom>
+          <a:noFill/>
+        </p:spPr>
+        <p:txBody>
+          <a:bodyPr wrap="square">
+            <a:spAutoFit/>
+          </a:bodyPr>
+          <a:lstStyle/>
+          <a:p>
+            <a:pPr algn="l"/>
+            <a:r>
+              <a:rPr sz="1100" b="1" i="0">
+                <a:solidFill>
+                  <a:srgbClr val="38BDF8"/>
+                </a:solidFill>
+              </a:rPr>
+              <a:t>$8,000</a:t>
+            </a:r>
+          </a:p>
+        </p:txBody>
+      </p:sp>
+      <p:sp>
+        <p:nvSpPr>
+          <p:cNvPr id="24" name="TextBox 23"/>
+          <p:cNvSpPr txBox="1"/>
+          <p:nvPr/>
+        </p:nvSpPr>
+        <p:spPr>
+          <a:xfrm>
+            <a:off x="8046720" y="5010912"/>
+            <a:ext cx="3291840" cy="502920"/>
+          </a:xfrm>
+          <a:prstGeom prst="rect">
+            <a:avLst/>
+          </a:prstGeom>
+          <a:noFill/>
+        </p:spPr>
+        <p:txBody>
+          <a:bodyPr wrap="square">
+            <a:spAutoFit/>
+          </a:bodyPr>
+          <a:lstStyle/>
+          <a:p>
+            <a:pPr algn="l"/>
+            <a:r>
+              <a:rPr sz="1100" b="0" i="0">
                 <a:solidFill>
                   <a:srgbClr val="CBD5E1"/>
                 </a:solidFill>
               </a:rPr>
-              <a:t>→  D2: Full i18n expansion  (optional)</a:t>
-            </a:r>
-          </a:p>
-          <a:p>
-            <a:pPr>
-              <a:spcBef>
-                <a:spcPts val="700"/>
-              </a:spcBef>
-            </a:pPr>
-            <a:r>
-              <a:rPr sz="1300">
-                <a:solidFill>
-                  <a:srgbClr val="CBD5E1"/>
-                </a:solidFill>
-              </a:rPr>
-              <a:t>→  D3: Dark mode prototype on branch  (optional)</a:t>
-            </a:r>
-          </a:p>
-          <a:p>
-            <a:pPr>
-              <a:spcBef>
-                <a:spcPts val="700"/>
-              </a:spcBef>
-            </a:pPr>
-            <a:r>
-              <a:rPr sz="1300">
-                <a:solidFill>
-                  <a:srgbClr val="CBD5E1"/>
-                </a:solidFill>
-              </a:rPr>
-              <a:t>→  PR merge + Meridian IT walkthrough</a:t>
+              <a:t>CSS variable theming. Prototype on a worktree branch, merge when approved.</a:t>
+            </a:r>
+          </a:p>
+        </p:txBody>
+      </p:sp>
+      <p:sp>
+        <p:nvSpPr>
+          <p:cNvPr id="25" name="TextBox 24"/>
+          <p:cNvSpPr txBox="1"/>
+          <p:nvPr/>
+        </p:nvSpPr>
+        <p:spPr>
+          <a:xfrm>
+            <a:off x="548640" y="6492240"/>
+            <a:ext cx="10972800" cy="320040"/>
+          </a:xfrm>
+          <a:prstGeom prst="rect">
+            <a:avLst/>
+          </a:prstGeom>
+          <a:noFill/>
+        </p:spPr>
+        <p:txBody>
+          <a:bodyPr wrap="square">
+            <a:spAutoFit/>
+          </a:bodyPr>
+          <a:lstStyle/>
+          <a:p>
+            <a:pPr algn="l"/>
+            <a:r>
+              <a:rPr sz="1100" b="0" i="0">
+                <a:solidFill>
+                  <a:srgbClr val="475569"/>
+                </a:solidFill>
+              </a:rPr>
+              <a:t>RFP #MC-2026-0417  ·  April 27, 2026  ·  Feature branch ready for PR review</a:t>
             </a:r>
           </a:p>
         </p:txBody>

</xml_diff>

<commit_message>
Deliver D1+D2+D3: CSS variables, Italian locale, dark mode toggle
D1: Refactor App.vue and FilterBar.vue to use CSS custom properties
throughout, making all layout/color tokens themeable.

D2: Add Italian (it.js) locale with full translations for all keys;
wire into useI18n.js (EUR currency, translateWarehouse map) and
LanguageSwitcher.vue.

D3: Add sun/moon dark mode toggle button to nav; isDark ref persisted
to localStorage; .dark class on <html> overrides CSS variables for a
complete dark theme across all views.

Co-Authored-By: Claude Sonnet 4.6 <noreply@anthropic.com>
</commit_message>
<xml_diff>
--- a/proposal/progress-report.pptx
+++ b/proposal/progress-report.pptx
@@ -5,15 +5,15 @@
     <p:sldMasterId id="2147483648" r:id="rId1"/>
   </p:sldMasterIdLst>
   <p:sldIdLst>
-    <p:sldId id="256" r:id="rId7"/>
-    <p:sldId id="257" r:id="rId8"/>
-    <p:sldId id="258" r:id="rId9"/>
-    <p:sldId id="259" r:id="rId10"/>
-    <p:sldId id="260" r:id="rId11"/>
-    <p:sldId id="261" r:id="rId12"/>
-    <p:sldId id="262" r:id="rId13"/>
+    <p:sldId id="256" r:id="rId2"/>
+    <p:sldId id="257" r:id="rId3"/>
+    <p:sldId id="258" r:id="rId4"/>
+    <p:sldId id="259" r:id="rId5"/>
+    <p:sldId id="260" r:id="rId6"/>
+    <p:sldId id="261" r:id="rId7"/>
+    <p:sldId id="262" r:id="rId8"/>
   </p:sldIdLst>
-  <p:sldSz cx="12188952" cy="6858000" type="screen4x3"/>
+  <p:sldSz cx="12188825" cy="6858000"/>
   <p:notesSz cx="6858000" cy="9144000"/>
   <p:defaultTextStyle>
     <a:defPPr>
@@ -110,6 +110,22 @@
       </a:defRPr>
     </a:lvl9pPr>
   </p:defaultTextStyle>
+  <p:extLst>
+    <p:ext uri="{EFAFB233-063F-42B5-8137-9DF3F51BA10A}">
+      <p15:sldGuideLst xmlns:p15="http://schemas.microsoft.com/office/powerpoint/2012/main">
+        <p15:guide id="1" orient="horz" pos="2160">
+          <p15:clr>
+            <a:srgbClr val="A4A3A4"/>
+          </p15:clr>
+        </p15:guide>
+        <p15:guide id="2" pos="2880">
+          <p15:clr>
+            <a:srgbClr val="A4A3A4"/>
+          </p15:clr>
+        </p15:guide>
+      </p15:sldGuideLst>
+    </p:ext>
+  </p:extLst>
 </p:presentation>
 </file>
 
@@ -151,10 +167,9 @@
           <a:lstStyle/>
           <a:p>
             <a:r>
-              <a:rPr lang="en-US" smtClean="0"/>
+              <a:rPr lang="en-US"/>
               <a:t>Click to edit Master title style</a:t>
             </a:r>
-            <a:endParaRPr lang="en-US"/>
           </a:p>
         </p:txBody>
       </p:sp>
@@ -270,10 +285,9 @@
           </a:lstStyle>
           <a:p>
             <a:r>
-              <a:rPr lang="en-US" smtClean="0"/>
+              <a:rPr lang="en-US"/>
               <a:t>Click to edit Master subtitle style</a:t>
             </a:r>
-            <a:endParaRPr lang="en-US"/>
           </a:p>
         </p:txBody>
       </p:sp>
@@ -294,7 +308,7 @@
           <a:p>
             <a:fld id="{5BCAD085-E8A6-8845-BD4E-CB4CCA059FC4}" type="datetimeFigureOut">
               <a:rPr lang="en-US" smtClean="0"/>
-              <a:t>1/27/13</a:t>
+              <a:t>4/27/2026</a:t>
             </a:fld>
             <a:endParaRPr lang="en-US"/>
           </a:p>
@@ -388,10 +402,9 @@
           <a:lstStyle/>
           <a:p>
             <a:r>
-              <a:rPr lang="en-US" smtClean="0"/>
+              <a:rPr lang="en-US"/>
               <a:t>Click to edit Master title style</a:t>
             </a:r>
-            <a:endParaRPr lang="en-US"/>
           </a:p>
         </p:txBody>
       </p:sp>
@@ -412,38 +425,37 @@
           <a:p>
             <a:pPr lvl="0"/>
             <a:r>
-              <a:rPr lang="en-US" smtClean="0"/>
+              <a:rPr lang="en-US"/>
               <a:t>Click to edit Master text styles</a:t>
             </a:r>
           </a:p>
           <a:p>
             <a:pPr lvl="1"/>
             <a:r>
-              <a:rPr lang="en-US" smtClean="0"/>
+              <a:rPr lang="en-US"/>
               <a:t>Second level</a:t>
             </a:r>
           </a:p>
           <a:p>
             <a:pPr lvl="2"/>
             <a:r>
-              <a:rPr lang="en-US" smtClean="0"/>
+              <a:rPr lang="en-US"/>
               <a:t>Third level</a:t>
             </a:r>
           </a:p>
           <a:p>
             <a:pPr lvl="3"/>
             <a:r>
-              <a:rPr lang="en-US" smtClean="0"/>
+              <a:rPr lang="en-US"/>
               <a:t>Fourth level</a:t>
             </a:r>
           </a:p>
           <a:p>
             <a:pPr lvl="4"/>
             <a:r>
-              <a:rPr lang="en-US" smtClean="0"/>
+              <a:rPr lang="en-US"/>
               <a:t>Fifth level</a:t>
             </a:r>
-            <a:endParaRPr lang="en-US"/>
           </a:p>
         </p:txBody>
       </p:sp>
@@ -464,7 +476,7 @@
           <a:p>
             <a:fld id="{5BCAD085-E8A6-8845-BD4E-CB4CCA059FC4}" type="datetimeFigureOut">
               <a:rPr lang="en-US" smtClean="0"/>
-              <a:t>1/27/13</a:t>
+              <a:t>4/27/2026</a:t>
             </a:fld>
             <a:endParaRPr lang="en-US"/>
           </a:p>
@@ -563,10 +575,9 @@
           <a:lstStyle/>
           <a:p>
             <a:r>
-              <a:rPr lang="en-US" smtClean="0"/>
+              <a:rPr lang="en-US"/>
               <a:t>Click to edit Master title style</a:t>
             </a:r>
-            <a:endParaRPr lang="en-US"/>
           </a:p>
         </p:txBody>
       </p:sp>
@@ -592,38 +603,37 @@
           <a:p>
             <a:pPr lvl="0"/>
             <a:r>
-              <a:rPr lang="en-US" smtClean="0"/>
+              <a:rPr lang="en-US"/>
               <a:t>Click to edit Master text styles</a:t>
             </a:r>
           </a:p>
           <a:p>
             <a:pPr lvl="1"/>
             <a:r>
-              <a:rPr lang="en-US" smtClean="0"/>
+              <a:rPr lang="en-US"/>
               <a:t>Second level</a:t>
             </a:r>
           </a:p>
           <a:p>
             <a:pPr lvl="2"/>
             <a:r>
-              <a:rPr lang="en-US" smtClean="0"/>
+              <a:rPr lang="en-US"/>
               <a:t>Third level</a:t>
             </a:r>
           </a:p>
           <a:p>
             <a:pPr lvl="3"/>
             <a:r>
-              <a:rPr lang="en-US" smtClean="0"/>
+              <a:rPr lang="en-US"/>
               <a:t>Fourth level</a:t>
             </a:r>
           </a:p>
           <a:p>
             <a:pPr lvl="4"/>
             <a:r>
-              <a:rPr lang="en-US" smtClean="0"/>
+              <a:rPr lang="en-US"/>
               <a:t>Fifth level</a:t>
             </a:r>
-            <a:endParaRPr lang="en-US"/>
           </a:p>
         </p:txBody>
       </p:sp>
@@ -644,7 +654,7 @@
           <a:p>
             <a:fld id="{5BCAD085-E8A6-8845-BD4E-CB4CCA059FC4}" type="datetimeFigureOut">
               <a:rPr lang="en-US" smtClean="0"/>
-              <a:t>1/27/13</a:t>
+              <a:t>4/27/2026</a:t>
             </a:fld>
             <a:endParaRPr lang="en-US"/>
           </a:p>
@@ -738,10 +748,9 @@
           <a:lstStyle/>
           <a:p>
             <a:r>
-              <a:rPr lang="en-US" smtClean="0"/>
+              <a:rPr lang="en-US"/>
               <a:t>Click to edit Master title style</a:t>
             </a:r>
-            <a:endParaRPr lang="en-US"/>
           </a:p>
         </p:txBody>
       </p:sp>
@@ -762,38 +771,37 @@
           <a:p>
             <a:pPr lvl="0"/>
             <a:r>
-              <a:rPr lang="en-US" smtClean="0"/>
+              <a:rPr lang="en-US"/>
               <a:t>Click to edit Master text styles</a:t>
             </a:r>
           </a:p>
           <a:p>
             <a:pPr lvl="1"/>
             <a:r>
-              <a:rPr lang="en-US" smtClean="0"/>
+              <a:rPr lang="en-US"/>
               <a:t>Second level</a:t>
             </a:r>
           </a:p>
           <a:p>
             <a:pPr lvl="2"/>
             <a:r>
-              <a:rPr lang="en-US" smtClean="0"/>
+              <a:rPr lang="en-US"/>
               <a:t>Third level</a:t>
             </a:r>
           </a:p>
           <a:p>
             <a:pPr lvl="3"/>
             <a:r>
-              <a:rPr lang="en-US" smtClean="0"/>
+              <a:rPr lang="en-US"/>
               <a:t>Fourth level</a:t>
             </a:r>
           </a:p>
           <a:p>
             <a:pPr lvl="4"/>
             <a:r>
-              <a:rPr lang="en-US" smtClean="0"/>
+              <a:rPr lang="en-US"/>
               <a:t>Fifth level</a:t>
             </a:r>
-            <a:endParaRPr lang="en-US"/>
           </a:p>
         </p:txBody>
       </p:sp>
@@ -814,7 +822,7 @@
           <a:p>
             <a:fld id="{5BCAD085-E8A6-8845-BD4E-CB4CCA059FC4}" type="datetimeFigureOut">
               <a:rPr lang="en-US" smtClean="0"/>
-              <a:t>1/27/13</a:t>
+              <a:t>4/27/2026</a:t>
             </a:fld>
             <a:endParaRPr lang="en-US"/>
           </a:p>
@@ -917,10 +925,9 @@
           </a:lstStyle>
           <a:p>
             <a:r>
-              <a:rPr lang="en-US" smtClean="0"/>
+              <a:rPr lang="en-US"/>
               <a:t>Click to edit Master title style</a:t>
             </a:r>
-            <a:endParaRPr lang="en-US"/>
           </a:p>
         </p:txBody>
       </p:sp>
@@ -1037,7 +1044,7 @@
           <a:p>
             <a:pPr lvl="0"/>
             <a:r>
-              <a:rPr lang="en-US" smtClean="0"/>
+              <a:rPr lang="en-US"/>
               <a:t>Click to edit Master text styles</a:t>
             </a:r>
           </a:p>
@@ -1060,7 +1067,7 @@
           <a:p>
             <a:fld id="{5BCAD085-E8A6-8845-BD4E-CB4CCA059FC4}" type="datetimeFigureOut">
               <a:rPr lang="en-US" smtClean="0"/>
-              <a:t>1/27/13</a:t>
+              <a:t>4/27/2026</a:t>
             </a:fld>
             <a:endParaRPr lang="en-US"/>
           </a:p>
@@ -1154,10 +1161,9 @@
           <a:lstStyle/>
           <a:p>
             <a:r>
-              <a:rPr lang="en-US" smtClean="0"/>
+              <a:rPr lang="en-US"/>
               <a:t>Click to edit Master title style</a:t>
             </a:r>
-            <a:endParaRPr lang="en-US"/>
           </a:p>
         </p:txBody>
       </p:sp>
@@ -1211,38 +1217,37 @@
           <a:p>
             <a:pPr lvl="0"/>
             <a:r>
-              <a:rPr lang="en-US" smtClean="0"/>
+              <a:rPr lang="en-US"/>
               <a:t>Click to edit Master text styles</a:t>
             </a:r>
           </a:p>
           <a:p>
             <a:pPr lvl="1"/>
             <a:r>
-              <a:rPr lang="en-US" smtClean="0"/>
+              <a:rPr lang="en-US"/>
               <a:t>Second level</a:t>
             </a:r>
           </a:p>
           <a:p>
             <a:pPr lvl="2"/>
             <a:r>
-              <a:rPr lang="en-US" smtClean="0"/>
+              <a:rPr lang="en-US"/>
               <a:t>Third level</a:t>
             </a:r>
           </a:p>
           <a:p>
             <a:pPr lvl="3"/>
             <a:r>
-              <a:rPr lang="en-US" smtClean="0"/>
+              <a:rPr lang="en-US"/>
               <a:t>Fourth level</a:t>
             </a:r>
           </a:p>
           <a:p>
             <a:pPr lvl="4"/>
             <a:r>
-              <a:rPr lang="en-US" smtClean="0"/>
+              <a:rPr lang="en-US"/>
               <a:t>Fifth level</a:t>
             </a:r>
-            <a:endParaRPr lang="en-US"/>
           </a:p>
         </p:txBody>
       </p:sp>
@@ -1296,38 +1301,37 @@
           <a:p>
             <a:pPr lvl="0"/>
             <a:r>
-              <a:rPr lang="en-US" smtClean="0"/>
+              <a:rPr lang="en-US"/>
               <a:t>Click to edit Master text styles</a:t>
             </a:r>
           </a:p>
           <a:p>
             <a:pPr lvl="1"/>
             <a:r>
-              <a:rPr lang="en-US" smtClean="0"/>
+              <a:rPr lang="en-US"/>
               <a:t>Second level</a:t>
             </a:r>
           </a:p>
           <a:p>
             <a:pPr lvl="2"/>
             <a:r>
-              <a:rPr lang="en-US" smtClean="0"/>
+              <a:rPr lang="en-US"/>
               <a:t>Third level</a:t>
             </a:r>
           </a:p>
           <a:p>
             <a:pPr lvl="3"/>
             <a:r>
-              <a:rPr lang="en-US" smtClean="0"/>
+              <a:rPr lang="en-US"/>
               <a:t>Fourth level</a:t>
             </a:r>
           </a:p>
           <a:p>
             <a:pPr lvl="4"/>
             <a:r>
-              <a:rPr lang="en-US" smtClean="0"/>
+              <a:rPr lang="en-US"/>
               <a:t>Fifth level</a:t>
             </a:r>
-            <a:endParaRPr lang="en-US"/>
           </a:p>
         </p:txBody>
       </p:sp>
@@ -1348,7 +1352,7 @@
           <a:p>
             <a:fld id="{5BCAD085-E8A6-8845-BD4E-CB4CCA059FC4}" type="datetimeFigureOut">
               <a:rPr lang="en-US" smtClean="0"/>
-              <a:t>1/27/13</a:t>
+              <a:t>4/27/2026</a:t>
             </a:fld>
             <a:endParaRPr lang="en-US"/>
           </a:p>
@@ -1446,10 +1450,9 @@
           </a:lstStyle>
           <a:p>
             <a:r>
-              <a:rPr lang="en-US" smtClean="0"/>
+              <a:rPr lang="en-US"/>
               <a:t>Click to edit Master title style</a:t>
             </a:r>
-            <a:endParaRPr lang="en-US"/>
           </a:p>
         </p:txBody>
       </p:sp>
@@ -1512,7 +1515,7 @@
           <a:p>
             <a:pPr lvl="0"/>
             <a:r>
-              <a:rPr lang="en-US" smtClean="0"/>
+              <a:rPr lang="en-US"/>
               <a:t>Click to edit Master text styles</a:t>
             </a:r>
           </a:p>
@@ -1568,38 +1571,37 @@
           <a:p>
             <a:pPr lvl="0"/>
             <a:r>
-              <a:rPr lang="en-US" smtClean="0"/>
+              <a:rPr lang="en-US"/>
               <a:t>Click to edit Master text styles</a:t>
             </a:r>
           </a:p>
           <a:p>
             <a:pPr lvl="1"/>
             <a:r>
-              <a:rPr lang="en-US" smtClean="0"/>
+              <a:rPr lang="en-US"/>
               <a:t>Second level</a:t>
             </a:r>
           </a:p>
           <a:p>
             <a:pPr lvl="2"/>
             <a:r>
-              <a:rPr lang="en-US" smtClean="0"/>
+              <a:rPr lang="en-US"/>
               <a:t>Third level</a:t>
             </a:r>
           </a:p>
           <a:p>
             <a:pPr lvl="3"/>
             <a:r>
-              <a:rPr lang="en-US" smtClean="0"/>
+              <a:rPr lang="en-US"/>
               <a:t>Fourth level</a:t>
             </a:r>
           </a:p>
           <a:p>
             <a:pPr lvl="4"/>
             <a:r>
-              <a:rPr lang="en-US" smtClean="0"/>
+              <a:rPr lang="en-US"/>
               <a:t>Fifth level</a:t>
             </a:r>
-            <a:endParaRPr lang="en-US"/>
           </a:p>
         </p:txBody>
       </p:sp>
@@ -1662,7 +1664,7 @@
           <a:p>
             <a:pPr lvl="0"/>
             <a:r>
-              <a:rPr lang="en-US" smtClean="0"/>
+              <a:rPr lang="en-US"/>
               <a:t>Click to edit Master text styles</a:t>
             </a:r>
           </a:p>
@@ -1718,38 +1720,37 @@
           <a:p>
             <a:pPr lvl="0"/>
             <a:r>
-              <a:rPr lang="en-US" smtClean="0"/>
+              <a:rPr lang="en-US"/>
               <a:t>Click to edit Master text styles</a:t>
             </a:r>
           </a:p>
           <a:p>
             <a:pPr lvl="1"/>
             <a:r>
-              <a:rPr lang="en-US" smtClean="0"/>
+              <a:rPr lang="en-US"/>
               <a:t>Second level</a:t>
             </a:r>
           </a:p>
           <a:p>
             <a:pPr lvl="2"/>
             <a:r>
-              <a:rPr lang="en-US" smtClean="0"/>
+              <a:rPr lang="en-US"/>
               <a:t>Third level</a:t>
             </a:r>
           </a:p>
           <a:p>
             <a:pPr lvl="3"/>
             <a:r>
-              <a:rPr lang="en-US" smtClean="0"/>
+              <a:rPr lang="en-US"/>
               <a:t>Fourth level</a:t>
             </a:r>
           </a:p>
           <a:p>
             <a:pPr lvl="4"/>
             <a:r>
-              <a:rPr lang="en-US" smtClean="0"/>
+              <a:rPr lang="en-US"/>
               <a:t>Fifth level</a:t>
             </a:r>
-            <a:endParaRPr lang="en-US"/>
           </a:p>
         </p:txBody>
       </p:sp>
@@ -1770,7 +1771,7 @@
           <a:p>
             <a:fld id="{5BCAD085-E8A6-8845-BD4E-CB4CCA059FC4}" type="datetimeFigureOut">
               <a:rPr lang="en-US" smtClean="0"/>
-              <a:t>1/27/13</a:t>
+              <a:t>4/27/2026</a:t>
             </a:fld>
             <a:endParaRPr lang="en-US"/>
           </a:p>
@@ -1864,10 +1865,9 @@
           <a:lstStyle/>
           <a:p>
             <a:r>
-              <a:rPr lang="en-US" smtClean="0"/>
+              <a:rPr lang="en-US"/>
               <a:t>Click to edit Master title style</a:t>
             </a:r>
-            <a:endParaRPr lang="en-US"/>
           </a:p>
         </p:txBody>
       </p:sp>
@@ -1888,7 +1888,7 @@
           <a:p>
             <a:fld id="{5BCAD085-E8A6-8845-BD4E-CB4CCA059FC4}" type="datetimeFigureOut">
               <a:rPr lang="en-US" smtClean="0"/>
-              <a:t>1/27/13</a:t>
+              <a:t>4/27/2026</a:t>
             </a:fld>
             <a:endParaRPr lang="en-US"/>
           </a:p>
@@ -1983,7 +1983,7 @@
           <a:p>
             <a:fld id="{5BCAD085-E8A6-8845-BD4E-CB4CCA059FC4}" type="datetimeFigureOut">
               <a:rPr lang="en-US" smtClean="0"/>
-              <a:t>1/27/13</a:t>
+              <a:t>4/27/2026</a:t>
             </a:fld>
             <a:endParaRPr lang="en-US"/>
           </a:p>
@@ -2086,10 +2086,9 @@
           </a:lstStyle>
           <a:p>
             <a:r>
-              <a:rPr lang="en-US" smtClean="0"/>
+              <a:rPr lang="en-US"/>
               <a:t>Click to edit Master title style</a:t>
             </a:r>
-            <a:endParaRPr lang="en-US"/>
           </a:p>
         </p:txBody>
       </p:sp>
@@ -2143,38 +2142,37 @@
           <a:p>
             <a:pPr lvl="0"/>
             <a:r>
-              <a:rPr lang="en-US" smtClean="0"/>
+              <a:rPr lang="en-US"/>
               <a:t>Click to edit Master text styles</a:t>
             </a:r>
           </a:p>
           <a:p>
             <a:pPr lvl="1"/>
             <a:r>
-              <a:rPr lang="en-US" smtClean="0"/>
+              <a:rPr lang="en-US"/>
               <a:t>Second level</a:t>
             </a:r>
           </a:p>
           <a:p>
             <a:pPr lvl="2"/>
             <a:r>
-              <a:rPr lang="en-US" smtClean="0"/>
+              <a:rPr lang="en-US"/>
               <a:t>Third level</a:t>
             </a:r>
           </a:p>
           <a:p>
             <a:pPr lvl="3"/>
             <a:r>
-              <a:rPr lang="en-US" smtClean="0"/>
+              <a:rPr lang="en-US"/>
               <a:t>Fourth level</a:t>
             </a:r>
           </a:p>
           <a:p>
             <a:pPr lvl="4"/>
             <a:r>
-              <a:rPr lang="en-US" smtClean="0"/>
+              <a:rPr lang="en-US"/>
               <a:t>Fifth level</a:t>
             </a:r>
-            <a:endParaRPr lang="en-US"/>
           </a:p>
         </p:txBody>
       </p:sp>
@@ -2237,7 +2235,7 @@
           <a:p>
             <a:pPr lvl="0"/>
             <a:r>
-              <a:rPr lang="en-US" smtClean="0"/>
+              <a:rPr lang="en-US"/>
               <a:t>Click to edit Master text styles</a:t>
             </a:r>
           </a:p>
@@ -2260,7 +2258,7 @@
           <a:p>
             <a:fld id="{5BCAD085-E8A6-8845-BD4E-CB4CCA059FC4}" type="datetimeFigureOut">
               <a:rPr lang="en-US" smtClean="0"/>
-              <a:t>1/27/13</a:t>
+              <a:t>4/27/2026</a:t>
             </a:fld>
             <a:endParaRPr lang="en-US"/>
           </a:p>
@@ -2363,10 +2361,9 @@
           </a:lstStyle>
           <a:p>
             <a:r>
-              <a:rPr lang="en-US" smtClean="0"/>
+              <a:rPr lang="en-US"/>
               <a:t>Click to edit Master title style</a:t>
             </a:r>
-            <a:endParaRPr lang="en-US"/>
           </a:p>
         </p:txBody>
       </p:sp>
@@ -2490,7 +2487,7 @@
           <a:p>
             <a:pPr lvl="0"/>
             <a:r>
-              <a:rPr lang="en-US" smtClean="0"/>
+              <a:rPr lang="en-US"/>
               <a:t>Click to edit Master text styles</a:t>
             </a:r>
           </a:p>
@@ -2513,7 +2510,7 @@
           <a:p>
             <a:fld id="{5BCAD085-E8A6-8845-BD4E-CB4CCA059FC4}" type="datetimeFigureOut">
               <a:rPr lang="en-US" smtClean="0"/>
-              <a:t>1/27/13</a:t>
+              <a:t>4/27/2026</a:t>
             </a:fld>
             <a:endParaRPr lang="en-US"/>
           </a:p>
@@ -2622,10 +2619,9 @@
           <a:lstStyle/>
           <a:p>
             <a:r>
-              <a:rPr lang="en-US" smtClean="0"/>
+              <a:rPr lang="en-US"/>
               <a:t>Click to edit Master title style</a:t>
             </a:r>
-            <a:endParaRPr lang="en-US"/>
           </a:p>
         </p:txBody>
       </p:sp>
@@ -2656,38 +2652,37 @@
           <a:p>
             <a:pPr lvl="0"/>
             <a:r>
-              <a:rPr lang="en-US" smtClean="0"/>
+              <a:rPr lang="en-US"/>
               <a:t>Click to edit Master text styles</a:t>
             </a:r>
           </a:p>
           <a:p>
             <a:pPr lvl="1"/>
             <a:r>
-              <a:rPr lang="en-US" smtClean="0"/>
+              <a:rPr lang="en-US"/>
               <a:t>Second level</a:t>
             </a:r>
           </a:p>
           <a:p>
             <a:pPr lvl="2"/>
             <a:r>
-              <a:rPr lang="en-US" smtClean="0"/>
+              <a:rPr lang="en-US"/>
               <a:t>Third level</a:t>
             </a:r>
           </a:p>
           <a:p>
             <a:pPr lvl="3"/>
             <a:r>
-              <a:rPr lang="en-US" smtClean="0"/>
+              <a:rPr lang="en-US"/>
               <a:t>Fourth level</a:t>
             </a:r>
           </a:p>
           <a:p>
             <a:pPr lvl="4"/>
             <a:r>
-              <a:rPr lang="en-US" smtClean="0"/>
+              <a:rPr lang="en-US"/>
               <a:t>Fifth level</a:t>
             </a:r>
-            <a:endParaRPr lang="en-US"/>
           </a:p>
         </p:txBody>
       </p:sp>
@@ -2726,7 +2721,7 @@
           <a:p>
             <a:fld id="{5BCAD085-E8A6-8845-BD4E-CB4CCA059FC4}" type="datetimeFigureOut">
               <a:rPr lang="en-US" smtClean="0"/>
-              <a:t>1/27/13</a:t>
+              <a:t>4/27/2026</a:t>
             </a:fld>
             <a:endParaRPr lang="en-US"/>
           </a:p>
@@ -3085,7 +3080,7 @@
 </file>
 
 <file path=ppt/slides/slide1.xml><?xml version="1.0" encoding="utf-8"?>
-<p:sld xmlns:a="http://schemas.openxmlformats.org/drawingml/2006/main" xmlns:p="http://schemas.openxmlformats.org/presentationml/2006/main" xmlns:r="http://schemas.openxmlformats.org/officeDocument/2006/relationships">
+<p:sld xmlns:a="http://schemas.openxmlformats.org/drawingml/2006/main" xmlns:r="http://schemas.openxmlformats.org/officeDocument/2006/relationships" xmlns:p="http://schemas.openxmlformats.org/presentationml/2006/main">
   <p:cSld>
     <p:bg>
       <p:bgPr>
@@ -3101,7 +3096,14 @@
         <p:cNvGrpSpPr/>
         <p:nvPr/>
       </p:nvGrpSpPr>
-      <p:grpSpPr/>
+      <p:grpSpPr>
+        <a:xfrm>
+          <a:off x="0" y="0"/>
+          <a:ext cx="0" cy="0"/>
+          <a:chOff x="0" y="0"/>
+          <a:chExt cx="0" cy="0"/>
+        </a:xfrm>
+      </p:grpSpPr>
       <p:sp>
         <p:nvSpPr>
           <p:cNvPr id="2" name="TextBox 1"/>
@@ -3214,22 +3216,22 @@
         <p:spPr>
           <a:xfrm>
             <a:off x="548640" y="1463040"/>
-            <a:ext cx="9144000" cy="1645920"/>
-          </a:xfrm>
-          <a:prstGeom prst="rect">
-            <a:avLst/>
-          </a:prstGeom>
-          <a:noFill/>
-        </p:spPr>
-        <p:txBody>
-          <a:bodyPr wrap="square">
-            <a:spAutoFit/>
-          </a:bodyPr>
-          <a:lstStyle/>
-          <a:p>
-            <a:pPr algn="l"/>
-            <a:r>
-              <a:rPr sz="4400" b="1" i="0">
+            <a:ext cx="9144000" cy="1446550"/>
+          </a:xfrm>
+          <a:prstGeom prst="rect">
+            <a:avLst/>
+          </a:prstGeom>
+          <a:noFill/>
+        </p:spPr>
+        <p:txBody>
+          <a:bodyPr wrap="square">
+            <a:spAutoFit/>
+          </a:bodyPr>
+          <a:lstStyle/>
+          <a:p>
+            <a:pPr algn="l"/>
+            <a:r>
+              <a:rPr lang="pt-BR" sz="4400" b="1" i="0">
                 <a:solidFill>
                   <a:srgbClr val="F8FAFC"/>
                 </a:solidFill>
@@ -3249,22 +3251,22 @@
         <p:spPr>
           <a:xfrm>
             <a:off x="548640" y="3474720"/>
-            <a:ext cx="8229600" cy="822960"/>
-          </a:xfrm>
-          <a:prstGeom prst="rect">
-            <a:avLst/>
-          </a:prstGeom>
-          <a:noFill/>
-        </p:spPr>
-        <p:txBody>
-          <a:bodyPr wrap="square">
-            <a:spAutoFit/>
-          </a:bodyPr>
-          <a:lstStyle/>
-          <a:p>
-            <a:pPr algn="l"/>
-            <a:r>
-              <a:rPr sz="1800" b="0" i="0">
+            <a:ext cx="8229600" cy="646331"/>
+          </a:xfrm>
+          <a:prstGeom prst="rect">
+            <a:avLst/>
+          </a:prstGeom>
+          <a:noFill/>
+        </p:spPr>
+        <p:txBody>
+          <a:bodyPr wrap="square">
+            <a:spAutoFit/>
+          </a:bodyPr>
+          <a:lstStyle/>
+          <a:p>
+            <a:pPr algn="l"/>
+            <a:r>
+              <a:rPr lang="en-US" sz="1800" b="0" i="0">
                 <a:solidFill>
                   <a:srgbClr val="94A3B8"/>
                 </a:solidFill>
@@ -3278,6 +3280,40 @@
       <p:sp>
         <p:nvSpPr>
           <p:cNvPr id="7" name="TextBox 6"/>
+          <p:cNvSpPr txBox="1"/>
+          <p:nvPr/>
+        </p:nvSpPr>
+        <p:spPr>
+          <a:xfrm>
+            <a:off x="548640" y="6217920"/>
+            <a:ext cx="4572000" cy="320040"/>
+          </a:xfrm>
+          <a:prstGeom prst="rect">
+            <a:avLst/>
+          </a:prstGeom>
+          <a:noFill/>
+        </p:spPr>
+        <p:txBody>
+          <a:bodyPr wrap="square">
+            <a:spAutoFit/>
+          </a:bodyPr>
+          <a:lstStyle/>
+          <a:p>
+            <a:pPr algn="l"/>
+            <a:r>
+              <a:rPr sz="1200" b="0" i="0">
+                <a:solidFill>
+                  <a:srgbClr val="475569"/>
+                </a:solidFill>
+              </a:rPr>
+              <a:t>April 27, 2026</a:t>
+            </a:r>
+          </a:p>
+        </p:txBody>
+      </p:sp>
+      <p:sp>
+        <p:nvSpPr>
+          <p:cNvPr id="9" name="TextBox 8"/>
           <p:cNvSpPr txBox="1"/>
           <p:nvPr/>
         </p:nvSpPr>
@@ -3318,7 +3354,7 @@
 </file>
 
 <file path=ppt/slides/slide2.xml><?xml version="1.0" encoding="utf-8"?>
-<p:sld xmlns:a="http://schemas.openxmlformats.org/drawingml/2006/main" xmlns:p="http://schemas.openxmlformats.org/presentationml/2006/main" xmlns:r="http://schemas.openxmlformats.org/officeDocument/2006/relationships">
+<p:sld xmlns:a="http://schemas.openxmlformats.org/drawingml/2006/main" xmlns:r="http://schemas.openxmlformats.org/officeDocument/2006/relationships" xmlns:p="http://schemas.openxmlformats.org/presentationml/2006/main">
   <p:cSld>
     <p:bg>
       <p:bgPr>
@@ -3334,7 +3370,14 @@
         <p:cNvGrpSpPr/>
         <p:nvPr/>
       </p:nvGrpSpPr>
-      <p:grpSpPr/>
+      <p:grpSpPr>
+        <a:xfrm>
+          <a:off x="0" y="0"/>
+          <a:ext cx="0" cy="0"/>
+          <a:chOff x="0" y="0"/>
+          <a:chExt cx="0" cy="0"/>
+        </a:xfrm>
+      </p:grpSpPr>
       <p:sp>
         <p:nvSpPr>
           <p:cNvPr id="2" name="TextBox 1"/>
@@ -3406,6 +3449,41 @@
       <p:cxnSp>
         <p:nvCxnSpPr>
           <p:cNvPr id="4" name="Connector 3"/>
+          <p:cNvCxnSpPr/>
+          <p:nvPr/>
+        </p:nvCxnSpPr>
+        <p:spPr>
+          <a:xfrm>
+            <a:off x="548640" y="868680"/>
+            <a:ext cx="1828800" cy="0"/>
+          </a:xfrm>
+          <a:prstGeom prst="line">
+            <a:avLst/>
+          </a:prstGeom>
+          <a:ln w="25400">
+            <a:solidFill>
+              <a:srgbClr val="38BDF8"/>
+            </a:solidFill>
+          </a:ln>
+        </p:spPr>
+        <p:style>
+          <a:lnRef idx="2">
+            <a:schemeClr val="accent1"/>
+          </a:lnRef>
+          <a:fillRef idx="0">
+            <a:schemeClr val="accent1"/>
+          </a:fillRef>
+          <a:effectRef idx="1">
+            <a:schemeClr val="accent1"/>
+          </a:effectRef>
+          <a:fontRef idx="minor">
+            <a:schemeClr val="tx1"/>
+          </a:fontRef>
+        </p:style>
+      </p:cxnSp>
+      <p:cxnSp>
+        <p:nvCxnSpPr>
+          <p:cNvPr id="35" name="Connector 3"/>
           <p:cNvCxnSpPr/>
           <p:nvPr/>
         </p:nvCxnSpPr>
@@ -3480,6 +3558,7 @@
           <a:lstStyle/>
           <a:p>
             <a:pPr algn="ctr"/>
+            <a:endParaRPr/>
           </a:p>
         </p:txBody>
       </p:sp>
@@ -3592,6 +3671,7 @@
           <a:lstStyle/>
           <a:p>
             <a:pPr algn="ctr"/>
+            <a:endParaRPr/>
           </a:p>
         </p:txBody>
       </p:sp>
@@ -3754,6 +3834,7 @@
           <a:lstStyle/>
           <a:p>
             <a:pPr algn="ctr"/>
+            <a:endParaRPr/>
           </a:p>
         </p:txBody>
       </p:sp>
@@ -3866,6 +3947,7 @@
           <a:lstStyle/>
           <a:p>
             <a:pPr algn="ctr"/>
+            <a:endParaRPr/>
           </a:p>
         </p:txBody>
       </p:sp>
@@ -4028,6 +4110,7 @@
           <a:lstStyle/>
           <a:p>
             <a:pPr algn="ctr"/>
+            <a:endParaRPr/>
           </a:p>
         </p:txBody>
       </p:sp>
@@ -4140,6 +4223,7 @@
           <a:lstStyle/>
           <a:p>
             <a:pPr algn="ctr"/>
+            <a:endParaRPr/>
           </a:p>
         </p:txBody>
       </p:sp>
@@ -4302,6 +4386,7 @@
           <a:lstStyle/>
           <a:p>
             <a:pPr algn="ctr"/>
+            <a:endParaRPr/>
           </a:p>
         </p:txBody>
       </p:sp>
@@ -4414,6 +4499,7 @@
           <a:lstStyle/>
           <a:p>
             <a:pPr algn="ctr"/>
+            <a:endParaRPr/>
           </a:p>
         </p:txBody>
       </p:sp>
@@ -4530,6 +4616,236 @@
                 </a:solidFill>
               </a:rPr>
               <a:t>• IT handoff notes</a:t>
+            </a:r>
+          </a:p>
+        </p:txBody>
+      </p:sp>
+      <p:sp>
+        <p:nvSpPr>
+          <p:cNvPr id="36" name="TextBox 35"/>
+          <p:cNvSpPr txBox="1"/>
+          <p:nvPr/>
+        </p:nvSpPr>
+        <p:spPr>
+          <a:xfrm>
+            <a:off x="9089136" y="2542032"/>
+            <a:ext cx="2377440" cy="347472"/>
+          </a:xfrm>
+          <a:prstGeom prst="rect">
+            <a:avLst/>
+          </a:prstGeom>
+          <a:noFill/>
+        </p:spPr>
+        <p:txBody>
+          <a:bodyPr wrap="square">
+            <a:spAutoFit/>
+          </a:bodyPr>
+          <a:lstStyle/>
+          <a:p>
+            <a:pPr algn="l"/>
+            <a:r>
+              <a:rPr sz="1100" b="1" i="0">
+                <a:solidFill>
+                  <a:srgbClr val="38BDF8"/>
+                </a:solidFill>
+              </a:rPr>
+              <a:t>R4</a:t>
+            </a:r>
+          </a:p>
+        </p:txBody>
+      </p:sp>
+      <p:sp>
+        <p:nvSpPr>
+          <p:cNvPr id="37" name="TextBox 36"/>
+          <p:cNvSpPr txBox="1"/>
+          <p:nvPr/>
+        </p:nvSpPr>
+        <p:spPr>
+          <a:xfrm>
+            <a:off x="9089136" y="2907792"/>
+            <a:ext cx="2377440" cy="502920"/>
+          </a:xfrm>
+          <a:prstGeom prst="rect">
+            <a:avLst/>
+          </a:prstGeom>
+          <a:noFill/>
+        </p:spPr>
+        <p:txBody>
+          <a:bodyPr wrap="square">
+            <a:spAutoFit/>
+          </a:bodyPr>
+          <a:lstStyle/>
+          <a:p>
+            <a:pPr algn="l"/>
+            <a:r>
+              <a:rPr sz="1500" b="1" i="0">
+                <a:solidFill>
+                  <a:srgbClr val="F8FAFC"/>
+                </a:solidFill>
+              </a:rPr>
+              <a:t>Architecture
+Docs</a:t>
+            </a:r>
+          </a:p>
+        </p:txBody>
+      </p:sp>
+      <p:sp>
+        <p:nvSpPr>
+          <p:cNvPr id="38" name="Rectangle 37"/>
+          <p:cNvSpPr/>
+          <p:nvPr/>
+        </p:nvSpPr>
+        <p:spPr>
+          <a:xfrm>
+            <a:off x="9089136" y="3456432"/>
+            <a:ext cx="1737360" cy="292608"/>
+          </a:xfrm>
+          <a:prstGeom prst="rect">
+            <a:avLst/>
+          </a:prstGeom>
+          <a:solidFill>
+            <a:srgbClr val="2D1F07"/>
+          </a:solidFill>
+          <a:ln>
+            <a:noFill/>
+          </a:ln>
+        </p:spPr>
+        <p:style>
+          <a:lnRef idx="1">
+            <a:schemeClr val="accent1"/>
+          </a:lnRef>
+          <a:fillRef idx="3">
+            <a:schemeClr val="accent1"/>
+          </a:fillRef>
+          <a:effectRef idx="2">
+            <a:schemeClr val="accent1"/>
+          </a:effectRef>
+          <a:fontRef idx="minor">
+            <a:schemeClr val="lt1"/>
+          </a:fontRef>
+        </p:style>
+        <p:txBody>
+          <a:bodyPr rtlCol="0" anchor="ctr"/>
+          <a:lstStyle/>
+          <a:p>
+            <a:pPr algn="ctr"/>
+            <a:endParaRPr/>
+          </a:p>
+        </p:txBody>
+      </p:sp>
+      <p:sp>
+        <p:nvSpPr>
+          <p:cNvPr id="39" name="TextBox 38"/>
+          <p:cNvSpPr txBox="1"/>
+          <p:nvPr/>
+        </p:nvSpPr>
+        <p:spPr>
+          <a:xfrm>
+            <a:off x="9162288" y="3483864"/>
+            <a:ext cx="1600200" cy="256032"/>
+          </a:xfrm>
+          <a:prstGeom prst="rect">
+            <a:avLst/>
+          </a:prstGeom>
+          <a:noFill/>
+        </p:spPr>
+        <p:txBody>
+          <a:bodyPr wrap="square">
+            <a:spAutoFit/>
+          </a:bodyPr>
+          <a:lstStyle/>
+          <a:p>
+            <a:pPr algn="ctr"/>
+            <a:r>
+              <a:rPr sz="1000" b="1" i="0">
+                <a:solidFill>
+                  <a:srgbClr val="F59E0B"/>
+                </a:solidFill>
+              </a:rPr>
+              <a:t>IN PROGRESS</a:t>
+            </a:r>
+          </a:p>
+        </p:txBody>
+      </p:sp>
+      <p:sp>
+        <p:nvSpPr>
+          <p:cNvPr id="40" name="TextBox 39"/>
+          <p:cNvSpPr txBox="1"/>
+          <p:nvPr/>
+        </p:nvSpPr>
+        <p:spPr>
+          <a:xfrm>
+            <a:off x="9089136" y="3913632"/>
+            <a:ext cx="2377440" cy="2011680"/>
+          </a:xfrm>
+          <a:prstGeom prst="rect">
+            <a:avLst/>
+          </a:prstGeom>
+          <a:noFill/>
+        </p:spPr>
+        <p:txBody>
+          <a:bodyPr wrap="square">
+            <a:spAutoFit/>
+          </a:bodyPr>
+          <a:lstStyle/>
+          <a:p>
+            <a:pPr>
+              <a:spcBef>
+                <a:spcPts val="500"/>
+              </a:spcBef>
+            </a:pPr>
+            <a:r>
+              <a:rPr sz="1200">
+                <a:solidFill>
+                  <a:srgbClr val="CBD5E1"/>
+                </a:solidFill>
+              </a:rPr>
+              <a:t>• HTML diagram</a:t>
+            </a:r>
+          </a:p>
+          <a:p>
+            <a:pPr>
+              <a:spcBef>
+                <a:spcPts val="500"/>
+              </a:spcBef>
+            </a:pPr>
+            <a:r>
+              <a:rPr sz="1200">
+                <a:solidFill>
+                  <a:srgbClr val="CBD5E1"/>
+                </a:solidFill>
+              </a:rPr>
+              <a:t>• Component map</a:t>
+            </a:r>
+          </a:p>
+          <a:p>
+            <a:pPr>
+              <a:spcBef>
+                <a:spcPts val="500"/>
+              </a:spcBef>
+            </a:pPr>
+            <a:r>
+              <a:rPr sz="1200">
+                <a:solidFill>
+                  <a:srgbClr val="CBD5E1"/>
+                </a:solidFill>
+              </a:rPr>
+              <a:t>• API endpoint list</a:t>
+            </a:r>
+          </a:p>
+          <a:p>
+            <a:pPr>
+              <a:spcBef>
+                <a:spcPts val="500"/>
+              </a:spcBef>
+            </a:pPr>
+            <a:r>
+              <a:rPr sz="1200">
+                <a:solidFill>
+                  <a:srgbClr val="CBD5E1"/>
+                </a:solidFill>
+              </a:rPr>
+              <a:t>• Meridian IT handoff</a:t>
             </a:r>
           </a:p>
         </p:txBody>
@@ -4543,7 +4859,7 @@
 </file>
 
 <file path=ppt/slides/slide3.xml><?xml version="1.0" encoding="utf-8"?>
-<p:sld xmlns:a="http://schemas.openxmlformats.org/drawingml/2006/main" xmlns:p="http://schemas.openxmlformats.org/presentationml/2006/main" xmlns:r="http://schemas.openxmlformats.org/officeDocument/2006/relationships">
+<p:sld xmlns:a="http://schemas.openxmlformats.org/drawingml/2006/main" xmlns:r="http://schemas.openxmlformats.org/officeDocument/2006/relationships" xmlns:p="http://schemas.openxmlformats.org/presentationml/2006/main">
   <p:cSld>
     <p:bg>
       <p:bgPr>
@@ -4559,7 +4875,14 @@
         <p:cNvGrpSpPr/>
         <p:nvPr/>
       </p:nvGrpSpPr>
-      <p:grpSpPr/>
+      <p:grpSpPr>
+        <a:xfrm>
+          <a:off x="0" y="0"/>
+          <a:ext cx="0" cy="0"/>
+          <a:chOff x="0" y="0"/>
+          <a:chExt cx="0" cy="0"/>
+        </a:xfrm>
+      </p:grpSpPr>
       <p:sp>
         <p:nvSpPr>
           <p:cNvPr id="2" name="Rectangle 1"/>
@@ -4600,6 +4923,7 @@
           <a:lstStyle/>
           <a:p>
             <a:pPr algn="ctr"/>
+            <a:endParaRPr/>
           </a:p>
         </p:txBody>
       </p:sp>
@@ -4748,6 +5072,7 @@
           <a:lstStyle/>
           <a:p>
             <a:pPr algn="ctr"/>
+            <a:endParaRPr/>
           </a:p>
         </p:txBody>
       </p:sp>
@@ -4861,6 +5186,7 @@
           <a:lstStyle/>
           <a:p>
             <a:pPr algn="ctr"/>
+            <a:endParaRPr/>
           </a:p>
         </p:txBody>
       </p:sp>
@@ -4974,6 +5300,7 @@
           <a:lstStyle/>
           <a:p>
             <a:pPr algn="ctr"/>
+            <a:endParaRPr/>
           </a:p>
         </p:txBody>
       </p:sp>
@@ -5087,6 +5414,7 @@
           <a:lstStyle/>
           <a:p>
             <a:pPr algn="ctr"/>
+            <a:endParaRPr/>
           </a:p>
         </p:txBody>
       </p:sp>
@@ -5127,6 +5455,416 @@
       <p:sp>
         <p:nvSpPr>
           <p:cNvPr id="17" name="TextBox 16"/>
+          <p:cNvSpPr txBox="1"/>
+          <p:nvPr/>
+        </p:nvSpPr>
+        <p:spPr>
+          <a:xfrm>
+            <a:off x="9107424" y="3017520"/>
+            <a:ext cx="2377440" cy="1280160"/>
+          </a:xfrm>
+          <a:prstGeom prst="rect">
+            <a:avLst/>
+          </a:prstGeom>
+          <a:noFill/>
+        </p:spPr>
+        <p:txBody>
+          <a:bodyPr wrap="square">
+            <a:spAutoFit/>
+          </a:bodyPr>
+          <a:lstStyle/>
+          <a:p>
+            <a:pPr algn="l"/>
+            <a:r>
+              <a:rPr sz="1200" b="0" i="0">
+                <a:solidFill>
+                  <a:srgbClr val="CBD5E1"/>
+                </a:solidFill>
+              </a:rPr>
+              <a:t>No console.log calls, no uncaught errors, no stray warnings on page load or filter change.</a:t>
+            </a:r>
+          </a:p>
+        </p:txBody>
+      </p:sp>
+      <p:sp>
+        <p:nvSpPr>
+          <p:cNvPr id="29" name="TextBox 28"/>
+          <p:cNvSpPr txBox="1"/>
+          <p:nvPr/>
+        </p:nvSpPr>
+        <p:spPr>
+          <a:xfrm>
+            <a:off x="685800" y="2560320"/>
+            <a:ext cx="2377440" cy="411480"/>
+          </a:xfrm>
+          <a:prstGeom prst="rect">
+            <a:avLst/>
+          </a:prstGeom>
+          <a:noFill/>
+        </p:spPr>
+        <p:txBody>
+          <a:bodyPr wrap="square">
+            <a:spAutoFit/>
+          </a:bodyPr>
+          <a:lstStyle/>
+          <a:p>
+            <a:pPr algn="l"/>
+            <a:r>
+              <a:rPr sz="1300" b="1" i="0">
+                <a:solidFill>
+                  <a:srgbClr val="38BDF8"/>
+                </a:solidFill>
+              </a:rPr>
+              <a:t>Options API → Composition API</a:t>
+            </a:r>
+          </a:p>
+        </p:txBody>
+      </p:sp>
+      <p:sp>
+        <p:nvSpPr>
+          <p:cNvPr id="30" name="TextBox 29"/>
+          <p:cNvSpPr txBox="1"/>
+          <p:nvPr/>
+        </p:nvSpPr>
+        <p:spPr>
+          <a:xfrm>
+            <a:off x="685800" y="3017520"/>
+            <a:ext cx="2377440" cy="1280160"/>
+          </a:xfrm>
+          <a:prstGeom prst="rect">
+            <a:avLst/>
+          </a:prstGeom>
+          <a:noFill/>
+        </p:spPr>
+        <p:txBody>
+          <a:bodyPr wrap="square">
+            <a:spAutoFit/>
+          </a:bodyPr>
+          <a:lstStyle/>
+          <a:p>
+            <a:pPr algn="l"/>
+            <a:r>
+              <a:rPr sz="1200" b="0" i="0">
+                <a:solidFill>
+                  <a:srgbClr val="CBD5E1"/>
+                </a:solidFill>
+              </a:rPr>
+              <a:t>Full rewrite of Reports.vue to Composition API pattern consistent with the rest of the codebase. Reactive state, watchers, computed properties.</a:t>
+            </a:r>
+          </a:p>
+        </p:txBody>
+      </p:sp>
+      <p:sp>
+        <p:nvSpPr>
+          <p:cNvPr id="31" name="Rectangle 30"/>
+          <p:cNvSpPr/>
+          <p:nvPr/>
+        </p:nvSpPr>
+        <p:spPr>
+          <a:xfrm>
+            <a:off x="3355848" y="2468880"/>
+            <a:ext cx="2651760" cy="2103120"/>
+          </a:xfrm>
+          <a:prstGeom prst="rect">
+            <a:avLst/>
+          </a:prstGeom>
+          <a:solidFill>
+            <a:srgbClr val="0F172A"/>
+          </a:solidFill>
+          <a:ln w="9525">
+            <a:solidFill>
+              <a:srgbClr val="334155"/>
+            </a:solidFill>
+          </a:ln>
+        </p:spPr>
+        <p:style>
+          <a:lnRef idx="1">
+            <a:schemeClr val="accent1"/>
+          </a:lnRef>
+          <a:fillRef idx="3">
+            <a:schemeClr val="accent1"/>
+          </a:fillRef>
+          <a:effectRef idx="2">
+            <a:schemeClr val="accent1"/>
+          </a:effectRef>
+          <a:fontRef idx="minor">
+            <a:schemeClr val="lt1"/>
+          </a:fontRef>
+        </p:style>
+        <p:txBody>
+          <a:bodyPr rtlCol="0" anchor="ctr"/>
+          <a:lstStyle/>
+          <a:p>
+            <a:pPr algn="ctr"/>
+            <a:endParaRPr/>
+          </a:p>
+        </p:txBody>
+      </p:sp>
+      <p:sp>
+        <p:nvSpPr>
+          <p:cNvPr id="32" name="TextBox 31"/>
+          <p:cNvSpPr txBox="1"/>
+          <p:nvPr/>
+        </p:nvSpPr>
+        <p:spPr>
+          <a:xfrm>
+            <a:off x="3493008" y="2560320"/>
+            <a:ext cx="2377440" cy="411480"/>
+          </a:xfrm>
+          <a:prstGeom prst="rect">
+            <a:avLst/>
+          </a:prstGeom>
+          <a:noFill/>
+        </p:spPr>
+        <p:txBody>
+          <a:bodyPr wrap="square">
+            <a:spAutoFit/>
+          </a:bodyPr>
+          <a:lstStyle/>
+          <a:p>
+            <a:pPr algn="l"/>
+            <a:r>
+              <a:rPr sz="1300" b="1" i="0">
+                <a:solidFill>
+                  <a:srgbClr val="38BDF8"/>
+                </a:solidFill>
+              </a:rPr>
+              <a:t>Filters fully wired</a:t>
+            </a:r>
+          </a:p>
+        </p:txBody>
+      </p:sp>
+      <p:sp>
+        <p:nvSpPr>
+          <p:cNvPr id="33" name="TextBox 32"/>
+          <p:cNvSpPr txBox="1"/>
+          <p:nvPr/>
+        </p:nvSpPr>
+        <p:spPr>
+          <a:xfrm>
+            <a:off x="3493008" y="3017520"/>
+            <a:ext cx="2377440" cy="1280160"/>
+          </a:xfrm>
+          <a:prstGeom prst="rect">
+            <a:avLst/>
+          </a:prstGeom>
+          <a:noFill/>
+        </p:spPr>
+        <p:txBody>
+          <a:bodyPr wrap="square">
+            <a:spAutoFit/>
+          </a:bodyPr>
+          <a:lstStyle/>
+          <a:p>
+            <a:pPr algn="l"/>
+            <a:r>
+              <a:rPr sz="1200" b="0" i="0">
+                <a:solidFill>
+                  <a:srgbClr val="CBD5E1"/>
+                </a:solidFill>
+              </a:rPr>
+              <a:t>Warehouse and Category params added to /api/reports/quarterly and /api/reports/monthly-trends. Watch on both filters triggers data reload.</a:t>
+            </a:r>
+          </a:p>
+        </p:txBody>
+      </p:sp>
+      <p:sp>
+        <p:nvSpPr>
+          <p:cNvPr id="34" name="Rectangle 33"/>
+          <p:cNvSpPr/>
+          <p:nvPr/>
+        </p:nvSpPr>
+        <p:spPr>
+          <a:xfrm>
+            <a:off x="6163056" y="2468880"/>
+            <a:ext cx="2651760" cy="2103120"/>
+          </a:xfrm>
+          <a:prstGeom prst="rect">
+            <a:avLst/>
+          </a:prstGeom>
+          <a:solidFill>
+            <a:srgbClr val="0F172A"/>
+          </a:solidFill>
+          <a:ln w="9525">
+            <a:solidFill>
+              <a:srgbClr val="334155"/>
+            </a:solidFill>
+          </a:ln>
+        </p:spPr>
+        <p:style>
+          <a:lnRef idx="1">
+            <a:schemeClr val="accent1"/>
+          </a:lnRef>
+          <a:fillRef idx="3">
+            <a:schemeClr val="accent1"/>
+          </a:fillRef>
+          <a:effectRef idx="2">
+            <a:schemeClr val="accent1"/>
+          </a:effectRef>
+          <a:fontRef idx="minor">
+            <a:schemeClr val="lt1"/>
+          </a:fontRef>
+        </p:style>
+        <p:txBody>
+          <a:bodyPr rtlCol="0" anchor="ctr"/>
+          <a:lstStyle/>
+          <a:p>
+            <a:pPr algn="ctr"/>
+            <a:endParaRPr/>
+          </a:p>
+        </p:txBody>
+      </p:sp>
+      <p:sp>
+        <p:nvSpPr>
+          <p:cNvPr id="35" name="TextBox 34"/>
+          <p:cNvSpPr txBox="1"/>
+          <p:nvPr/>
+        </p:nvSpPr>
+        <p:spPr>
+          <a:xfrm>
+            <a:off x="6300216" y="2560320"/>
+            <a:ext cx="2377440" cy="411480"/>
+          </a:xfrm>
+          <a:prstGeom prst="rect">
+            <a:avLst/>
+          </a:prstGeom>
+          <a:noFill/>
+        </p:spPr>
+        <p:txBody>
+          <a:bodyPr wrap="square">
+            <a:spAutoFit/>
+          </a:bodyPr>
+          <a:lstStyle/>
+          <a:p>
+            <a:pPr algn="l"/>
+            <a:r>
+              <a:rPr sz="1300" b="1" i="0">
+                <a:solidFill>
+                  <a:srgbClr val="38BDF8"/>
+                </a:solidFill>
+              </a:rPr>
+              <a:t>i18n gaps closed</a:t>
+            </a:r>
+          </a:p>
+        </p:txBody>
+      </p:sp>
+      <p:sp>
+        <p:nvSpPr>
+          <p:cNvPr id="36" name="TextBox 35"/>
+          <p:cNvSpPr txBox="1"/>
+          <p:nvPr/>
+        </p:nvSpPr>
+        <p:spPr>
+          <a:xfrm>
+            <a:off x="6300216" y="3017520"/>
+            <a:ext cx="2377440" cy="1280160"/>
+          </a:xfrm>
+          <a:prstGeom prst="rect">
+            <a:avLst/>
+          </a:prstGeom>
+          <a:noFill/>
+        </p:spPr>
+        <p:txBody>
+          <a:bodyPr wrap="square">
+            <a:spAutoFit/>
+          </a:bodyPr>
+          <a:lstStyle/>
+          <a:p>
+            <a:pPr algn="l"/>
+            <a:r>
+              <a:rPr sz="1200" b="0" i="0">
+                <a:solidFill>
+                  <a:srgbClr val="CBD5E1"/>
+                </a:solidFill>
+              </a:rPr>
+              <a:t>All labels, headings, and table columns routed through t() calls. English and Japanese locale keys complete.</a:t>
+            </a:r>
+          </a:p>
+        </p:txBody>
+      </p:sp>
+      <p:sp>
+        <p:nvSpPr>
+          <p:cNvPr id="37" name="Rectangle 36"/>
+          <p:cNvSpPr/>
+          <p:nvPr/>
+        </p:nvSpPr>
+        <p:spPr>
+          <a:xfrm>
+            <a:off x="8970264" y="2468880"/>
+            <a:ext cx="2651760" cy="2103120"/>
+          </a:xfrm>
+          <a:prstGeom prst="rect">
+            <a:avLst/>
+          </a:prstGeom>
+          <a:solidFill>
+            <a:srgbClr val="0F172A"/>
+          </a:solidFill>
+          <a:ln w="9525">
+            <a:solidFill>
+              <a:srgbClr val="334155"/>
+            </a:solidFill>
+          </a:ln>
+        </p:spPr>
+        <p:style>
+          <a:lnRef idx="1">
+            <a:schemeClr val="accent1"/>
+          </a:lnRef>
+          <a:fillRef idx="3">
+            <a:schemeClr val="accent1"/>
+          </a:fillRef>
+          <a:effectRef idx="2">
+            <a:schemeClr val="accent1"/>
+          </a:effectRef>
+          <a:fontRef idx="minor">
+            <a:schemeClr val="lt1"/>
+          </a:fontRef>
+        </p:style>
+        <p:txBody>
+          <a:bodyPr rtlCol="0" anchor="ctr"/>
+          <a:lstStyle/>
+          <a:p>
+            <a:pPr algn="ctr"/>
+            <a:endParaRPr/>
+          </a:p>
+        </p:txBody>
+      </p:sp>
+      <p:sp>
+        <p:nvSpPr>
+          <p:cNvPr id="38" name="TextBox 37"/>
+          <p:cNvSpPr txBox="1"/>
+          <p:nvPr/>
+        </p:nvSpPr>
+        <p:spPr>
+          <a:xfrm>
+            <a:off x="9107424" y="2560320"/>
+            <a:ext cx="2377440" cy="411480"/>
+          </a:xfrm>
+          <a:prstGeom prst="rect">
+            <a:avLst/>
+          </a:prstGeom>
+          <a:noFill/>
+        </p:spPr>
+        <p:txBody>
+          <a:bodyPr wrap="square">
+            <a:spAutoFit/>
+          </a:bodyPr>
+          <a:lstStyle/>
+          <a:p>
+            <a:pPr algn="l"/>
+            <a:r>
+              <a:rPr sz="1300" b="1" i="0">
+                <a:solidFill>
+                  <a:srgbClr val="38BDF8"/>
+                </a:solidFill>
+              </a:rPr>
+              <a:t>Console noise eliminated</a:t>
+            </a:r>
+          </a:p>
+        </p:txBody>
+      </p:sp>
+      <p:sp>
+        <p:nvSpPr>
+          <p:cNvPr id="39" name="TextBox 38"/>
           <p:cNvSpPr txBox="1"/>
           <p:nvPr/>
         </p:nvSpPr>
@@ -5167,7 +5905,7 @@
 </file>
 
 <file path=ppt/slides/slide4.xml><?xml version="1.0" encoding="utf-8"?>
-<p:sld xmlns:a="http://schemas.openxmlformats.org/drawingml/2006/main" xmlns:p="http://schemas.openxmlformats.org/presentationml/2006/main" xmlns:r="http://schemas.openxmlformats.org/officeDocument/2006/relationships">
+<p:sld xmlns:a="http://schemas.openxmlformats.org/drawingml/2006/main" xmlns:r="http://schemas.openxmlformats.org/officeDocument/2006/relationships" xmlns:p="http://schemas.openxmlformats.org/presentationml/2006/main">
   <p:cSld>
     <p:bg>
       <p:bgPr>
@@ -5183,7 +5921,14 @@
         <p:cNvGrpSpPr/>
         <p:nvPr/>
       </p:nvGrpSpPr>
-      <p:grpSpPr/>
+      <p:grpSpPr>
+        <a:xfrm>
+          <a:off x="0" y="0"/>
+          <a:ext cx="0" cy="0"/>
+          <a:chOff x="0" y="0"/>
+          <a:chExt cx="0" cy="0"/>
+        </a:xfrm>
+      </p:grpSpPr>
       <p:sp>
         <p:nvSpPr>
           <p:cNvPr id="2" name="Rectangle 1"/>
@@ -5224,6 +5969,7 @@
           <a:lstStyle/>
           <a:p>
             <a:pPr algn="ctr"/>
+            <a:endParaRPr/>
           </a:p>
         </p:txBody>
       </p:sp>
@@ -5372,6 +6118,7 @@
           <a:lstStyle/>
           <a:p>
             <a:pPr algn="ctr"/>
+            <a:endParaRPr/>
           </a:p>
         </p:txBody>
       </p:sp>
@@ -5564,6 +6311,7 @@
           <a:lstStyle/>
           <a:p>
             <a:pPr algn="ctr"/>
+            <a:endParaRPr/>
           </a:p>
         </p:txBody>
       </p:sp>
@@ -5842,6 +6590,244 @@
       <p:sp>
         <p:nvSpPr>
           <p:cNvPr id="18" name="TextBox 17"/>
+          <p:cNvSpPr txBox="1"/>
+          <p:nvPr/>
+        </p:nvSpPr>
+        <p:spPr>
+          <a:xfrm>
+            <a:off x="6446520" y="5358383"/>
+            <a:ext cx="5212080" cy="274320"/>
+          </a:xfrm>
+          <a:prstGeom prst="rect">
+            <a:avLst/>
+          </a:prstGeom>
+          <a:noFill/>
+        </p:spPr>
+        <p:txBody>
+          <a:bodyPr wrap="square">
+            <a:spAutoFit/>
+          </a:bodyPr>
+          <a:lstStyle/>
+          <a:p>
+            <a:pPr algn="l"/>
+            <a:r>
+              <a:rPr sz="1200" b="0" i="0">
+                <a:solidFill>
+                  <a:srgbClr val="94A3B8"/>
+                </a:solidFill>
+              </a:rPr>
+              <a:t>Unspent allocation</a:t>
+            </a:r>
+          </a:p>
+        </p:txBody>
+      </p:sp>
+      <p:sp>
+        <p:nvSpPr>
+          <p:cNvPr id="26" name="TextBox 25"/>
+          <p:cNvSpPr txBox="1"/>
+          <p:nvPr/>
+        </p:nvSpPr>
+        <p:spPr>
+          <a:xfrm>
+            <a:off x="6446520" y="3383279"/>
+            <a:ext cx="5212080" cy="274320"/>
+          </a:xfrm>
+          <a:prstGeom prst="rect">
+            <a:avLst/>
+          </a:prstGeom>
+          <a:noFill/>
+        </p:spPr>
+        <p:txBody>
+          <a:bodyPr wrap="square">
+            <a:spAutoFit/>
+          </a:bodyPr>
+          <a:lstStyle/>
+          <a:p>
+            <a:pPr algn="l"/>
+            <a:r>
+              <a:rPr sz="1200" b="0" i="0">
+                <a:solidFill>
+                  <a:srgbClr val="94A3B8"/>
+                </a:solidFill>
+              </a:rPr>
+              <a:t>23 SKUs understocked</a:t>
+            </a:r>
+          </a:p>
+        </p:txBody>
+      </p:sp>
+      <p:sp>
+        <p:nvSpPr>
+          <p:cNvPr id="27" name="TextBox 26"/>
+          <p:cNvSpPr txBox="1"/>
+          <p:nvPr/>
+        </p:nvSpPr>
+        <p:spPr>
+          <a:xfrm>
+            <a:off x="6446520" y="3767328"/>
+            <a:ext cx="5212080" cy="274320"/>
+          </a:xfrm>
+          <a:prstGeom prst="rect">
+            <a:avLst/>
+          </a:prstGeom>
+          <a:noFill/>
+        </p:spPr>
+        <p:txBody>
+          <a:bodyPr wrap="square">
+            <a:spAutoFit/>
+          </a:bodyPr>
+          <a:lstStyle/>
+          <a:p>
+            <a:pPr algn="l"/>
+            <a:r>
+              <a:rPr sz="1300" b="1" i="0">
+                <a:solidFill>
+                  <a:srgbClr val="38BDF8"/>
+                </a:solidFill>
+              </a:rPr>
+              <a:t>■  Total Restock Cost</a:t>
+            </a:r>
+          </a:p>
+        </p:txBody>
+      </p:sp>
+      <p:sp>
+        <p:nvSpPr>
+          <p:cNvPr id="28" name="TextBox 27"/>
+          <p:cNvSpPr txBox="1"/>
+          <p:nvPr/>
+        </p:nvSpPr>
+        <p:spPr>
+          <a:xfrm>
+            <a:off x="6446520" y="4041648"/>
+            <a:ext cx="5212080" cy="274320"/>
+          </a:xfrm>
+          <a:prstGeom prst="rect">
+            <a:avLst/>
+          </a:prstGeom>
+          <a:noFill/>
+        </p:spPr>
+        <p:txBody>
+          <a:bodyPr wrap="square">
+            <a:spAutoFit/>
+          </a:bodyPr>
+          <a:lstStyle/>
+          <a:p>
+            <a:pPr algn="l"/>
+            <a:r>
+              <a:rPr sz="1200" b="0" i="0">
+                <a:solidFill>
+                  <a:srgbClr val="94A3B8"/>
+                </a:solidFill>
+              </a:rPr>
+              <a:t>Full cost if all ordered</a:t>
+            </a:r>
+          </a:p>
+        </p:txBody>
+      </p:sp>
+      <p:sp>
+        <p:nvSpPr>
+          <p:cNvPr id="29" name="TextBox 28"/>
+          <p:cNvSpPr txBox="1"/>
+          <p:nvPr/>
+        </p:nvSpPr>
+        <p:spPr>
+          <a:xfrm>
+            <a:off x="6446520" y="4425696"/>
+            <a:ext cx="5212080" cy="274320"/>
+          </a:xfrm>
+          <a:prstGeom prst="rect">
+            <a:avLst/>
+          </a:prstGeom>
+          <a:noFill/>
+        </p:spPr>
+        <p:txBody>
+          <a:bodyPr wrap="square">
+            <a:spAutoFit/>
+          </a:bodyPr>
+          <a:lstStyle/>
+          <a:p>
+            <a:pPr algn="l"/>
+            <a:r>
+              <a:rPr sz="1300" b="1" i="0">
+                <a:solidFill>
+                  <a:srgbClr val="38BDF8"/>
+                </a:solidFill>
+              </a:rPr>
+              <a:t>■  Within Budget</a:t>
+            </a:r>
+          </a:p>
+        </p:txBody>
+      </p:sp>
+      <p:sp>
+        <p:nvSpPr>
+          <p:cNvPr id="30" name="TextBox 29"/>
+          <p:cNvSpPr txBox="1"/>
+          <p:nvPr/>
+        </p:nvSpPr>
+        <p:spPr>
+          <a:xfrm>
+            <a:off x="6446520" y="4700016"/>
+            <a:ext cx="5212080" cy="274320"/>
+          </a:xfrm>
+          <a:prstGeom prst="rect">
+            <a:avLst/>
+          </a:prstGeom>
+          <a:noFill/>
+        </p:spPr>
+        <p:txBody>
+          <a:bodyPr wrap="square">
+            <a:spAutoFit/>
+          </a:bodyPr>
+          <a:lstStyle/>
+          <a:p>
+            <a:pPr algn="l"/>
+            <a:r>
+              <a:rPr sz="1200" b="0" i="0">
+                <a:solidFill>
+                  <a:srgbClr val="94A3B8"/>
+                </a:solidFill>
+              </a:rPr>
+              <a:t>Items within ceiling</a:t>
+            </a:r>
+          </a:p>
+        </p:txBody>
+      </p:sp>
+      <p:sp>
+        <p:nvSpPr>
+          <p:cNvPr id="31" name="TextBox 30"/>
+          <p:cNvSpPr txBox="1"/>
+          <p:nvPr/>
+        </p:nvSpPr>
+        <p:spPr>
+          <a:xfrm>
+            <a:off x="6446520" y="5084064"/>
+            <a:ext cx="5212080" cy="274320"/>
+          </a:xfrm>
+          <a:prstGeom prst="rect">
+            <a:avLst/>
+          </a:prstGeom>
+          <a:noFill/>
+        </p:spPr>
+        <p:txBody>
+          <a:bodyPr wrap="square">
+            <a:spAutoFit/>
+          </a:bodyPr>
+          <a:lstStyle/>
+          <a:p>
+            <a:pPr algn="l"/>
+            <a:r>
+              <a:rPr sz="1300" b="1" i="0">
+                <a:solidFill>
+                  <a:srgbClr val="38BDF8"/>
+                </a:solidFill>
+              </a:rPr>
+              <a:t>■  Budget Remaining</a:t>
+            </a:r>
+          </a:p>
+        </p:txBody>
+      </p:sp>
+      <p:sp>
+        <p:nvSpPr>
+          <p:cNvPr id="32" name="TextBox 31"/>
           <p:cNvSpPr txBox="1"/>
           <p:nvPr/>
         </p:nvSpPr>
@@ -5882,7 +6868,7 @@
 </file>
 
 <file path=ppt/slides/slide5.xml><?xml version="1.0" encoding="utf-8"?>
-<p:sld xmlns:a="http://schemas.openxmlformats.org/drawingml/2006/main" xmlns:p="http://schemas.openxmlformats.org/presentationml/2006/main" xmlns:r="http://schemas.openxmlformats.org/officeDocument/2006/relationships">
+<p:sld xmlns:a="http://schemas.openxmlformats.org/drawingml/2006/main" xmlns:r="http://schemas.openxmlformats.org/officeDocument/2006/relationships" xmlns:p="http://schemas.openxmlformats.org/presentationml/2006/main">
   <p:cSld>
     <p:bg>
       <p:bgPr>
@@ -5898,7 +6884,14 @@
         <p:cNvGrpSpPr/>
         <p:nvPr/>
       </p:nvGrpSpPr>
-      <p:grpSpPr/>
+      <p:grpSpPr>
+        <a:xfrm>
+          <a:off x="0" y="0"/>
+          <a:ext cx="0" cy="0"/>
+          <a:chOff x="0" y="0"/>
+          <a:chExt cx="0" cy="0"/>
+        </a:xfrm>
+      </p:grpSpPr>
       <p:sp>
         <p:nvSpPr>
           <p:cNvPr id="2" name="Rectangle 1"/>
@@ -5939,6 +6932,7 @@
           <a:lstStyle/>
           <a:p>
             <a:pPr algn="ctr"/>
+            <a:endParaRPr/>
           </a:p>
         </p:txBody>
       </p:sp>
@@ -6154,6 +7148,7 @@
           <a:lstStyle/>
           <a:p>
             <a:pPr algn="ctr"/>
+            <a:endParaRPr/>
           </a:p>
         </p:txBody>
       </p:sp>
@@ -6301,6 +7296,7 @@
           <a:lstStyle/>
           <a:p>
             <a:pPr algn="ctr"/>
+            <a:endParaRPr/>
           </a:p>
         </p:txBody>
       </p:sp>
@@ -6448,6 +7444,7 @@
           <a:lstStyle/>
           <a:p>
             <a:pPr algn="ctr"/>
+            <a:endParaRPr/>
           </a:p>
         </p:txBody>
       </p:sp>
@@ -6595,6 +7592,7 @@
           <a:lstStyle/>
           <a:p>
             <a:pPr algn="ctr"/>
+            <a:endParaRPr/>
           </a:p>
         </p:txBody>
       </p:sp>
@@ -6742,6 +7740,7 @@
           <a:lstStyle/>
           <a:p>
             <a:pPr algn="ctr"/>
+            <a:endParaRPr/>
           </a:p>
         </p:txBody>
       </p:sp>
@@ -6889,6 +7888,7 @@
           <a:lstStyle/>
           <a:p>
             <a:pPr algn="ctr"/>
+            <a:endParaRPr/>
           </a:p>
         </p:txBody>
       </p:sp>
@@ -7036,6 +8036,7 @@
           <a:lstStyle/>
           <a:p>
             <a:pPr algn="ctr"/>
+            <a:endParaRPr/>
           </a:p>
         </p:txBody>
       </p:sp>
@@ -7183,6 +8184,7 @@
           <a:lstStyle/>
           <a:p>
             <a:pPr algn="ctr"/>
+            <a:endParaRPr/>
           </a:p>
         </p:txBody>
       </p:sp>
@@ -7330,6 +8332,7 @@
           <a:lstStyle/>
           <a:p>
             <a:pPr algn="ctr"/>
+            <a:endParaRPr/>
           </a:p>
         </p:txBody>
       </p:sp>
@@ -7404,6 +8407,1372 @@
       <p:sp>
         <p:nvSpPr>
           <p:cNvPr id="43" name="TextBox 42"/>
+          <p:cNvSpPr txBox="1"/>
+          <p:nvPr/>
+        </p:nvSpPr>
+        <p:spPr>
+          <a:xfrm>
+            <a:off x="8458200" y="4251960"/>
+            <a:ext cx="3474720" cy="256032"/>
+          </a:xfrm>
+          <a:prstGeom prst="rect">
+            <a:avLst/>
+          </a:prstGeom>
+          <a:noFill/>
+        </p:spPr>
+        <p:txBody>
+          <a:bodyPr wrap="square">
+            <a:spAutoFit/>
+          </a:bodyPr>
+          <a:lstStyle/>
+          <a:p>
+            <a:pPr algn="l"/>
+            <a:r>
+              <a:rPr sz="1000" b="0" i="0">
+                <a:solidFill>
+                  <a:srgbClr val="94A3B8"/>
+                </a:solidFill>
+              </a:rPr>
+              <a:t>Trend cards, table, filters</a:t>
+            </a:r>
+          </a:p>
+        </p:txBody>
+      </p:sp>
+      <p:sp>
+        <p:nvSpPr>
+          <p:cNvPr id="81" name="TextBox 80"/>
+          <p:cNvSpPr txBox="1"/>
+          <p:nvPr/>
+        </p:nvSpPr>
+        <p:spPr>
+          <a:xfrm>
+            <a:off x="9601200" y="2468880"/>
+            <a:ext cx="2286000" cy="365760"/>
+          </a:xfrm>
+          <a:prstGeom prst="rect">
+            <a:avLst/>
+          </a:prstGeom>
+          <a:noFill/>
+        </p:spPr>
+        <p:txBody>
+          <a:bodyPr wrap="square">
+            <a:spAutoFit/>
+          </a:bodyPr>
+          <a:lstStyle/>
+          <a:p>
+            <a:pPr algn="ctr"/>
+            <a:r>
+              <a:rPr sz="1400" b="0" i="0">
+                <a:solidFill>
+                  <a:srgbClr val="94A3B8"/>
+                </a:solidFill>
+              </a:rPr>
+              <a:t>passing</a:t>
+            </a:r>
+          </a:p>
+        </p:txBody>
+      </p:sp>
+      <p:sp>
+        <p:nvSpPr>
+          <p:cNvPr id="82" name="Rectangle 81"/>
+          <p:cNvSpPr/>
+          <p:nvPr/>
+        </p:nvSpPr>
+        <p:spPr>
+          <a:xfrm>
+            <a:off x="548640" y="2423160"/>
+            <a:ext cx="3749039" cy="640080"/>
+          </a:xfrm>
+          <a:prstGeom prst="rect">
+            <a:avLst/>
+          </a:prstGeom>
+          <a:solidFill>
+            <a:srgbClr val="0F172A"/>
+          </a:solidFill>
+          <a:ln w="9525">
+            <a:solidFill>
+              <a:srgbClr val="1E293B"/>
+            </a:solidFill>
+          </a:ln>
+        </p:spPr>
+        <p:style>
+          <a:lnRef idx="1">
+            <a:schemeClr val="accent1"/>
+          </a:lnRef>
+          <a:fillRef idx="3">
+            <a:schemeClr val="accent1"/>
+          </a:fillRef>
+          <a:effectRef idx="2">
+            <a:schemeClr val="accent1"/>
+          </a:effectRef>
+          <a:fontRef idx="minor">
+            <a:schemeClr val="lt1"/>
+          </a:fontRef>
+        </p:style>
+        <p:txBody>
+          <a:bodyPr rtlCol="0" anchor="ctr"/>
+          <a:lstStyle/>
+          <a:p>
+            <a:pPr algn="ctr"/>
+            <a:endParaRPr/>
+          </a:p>
+        </p:txBody>
+      </p:sp>
+      <p:sp>
+        <p:nvSpPr>
+          <p:cNvPr id="83" name="TextBox 82"/>
+          <p:cNvSpPr txBox="1"/>
+          <p:nvPr/>
+        </p:nvSpPr>
+        <p:spPr>
+          <a:xfrm>
+            <a:off x="685800" y="2478024"/>
+            <a:ext cx="2286000" cy="274320"/>
+          </a:xfrm>
+          <a:prstGeom prst="rect">
+            <a:avLst/>
+          </a:prstGeom>
+          <a:noFill/>
+        </p:spPr>
+        <p:txBody>
+          <a:bodyPr wrap="square">
+            <a:spAutoFit/>
+          </a:bodyPr>
+          <a:lstStyle/>
+          <a:p>
+            <a:pPr algn="l"/>
+            <a:r>
+              <a:rPr sz="1100" b="1" i="0">
+                <a:solidFill>
+                  <a:srgbClr val="38BDF8"/>
+                </a:solidFill>
+              </a:rPr>
+              <a:t>navigation.spec.js</a:t>
+            </a:r>
+          </a:p>
+        </p:txBody>
+      </p:sp>
+      <p:sp>
+        <p:nvSpPr>
+          <p:cNvPr id="84" name="TextBox 83"/>
+          <p:cNvSpPr txBox="1"/>
+          <p:nvPr/>
+        </p:nvSpPr>
+        <p:spPr>
+          <a:xfrm>
+            <a:off x="3108960" y="2478024"/>
+            <a:ext cx="1005840" cy="274320"/>
+          </a:xfrm>
+          <a:prstGeom prst="rect">
+            <a:avLst/>
+          </a:prstGeom>
+          <a:noFill/>
+        </p:spPr>
+        <p:txBody>
+          <a:bodyPr wrap="square">
+            <a:spAutoFit/>
+          </a:bodyPr>
+          <a:lstStyle/>
+          <a:p>
+            <a:pPr algn="r"/>
+            <a:r>
+              <a:rPr sz="1100" b="1" i="0">
+                <a:solidFill>
+                  <a:srgbClr val="22C55E"/>
+                </a:solidFill>
+              </a:rPr>
+              <a:t>3 tests</a:t>
+            </a:r>
+          </a:p>
+        </p:txBody>
+      </p:sp>
+      <p:sp>
+        <p:nvSpPr>
+          <p:cNvPr id="85" name="TextBox 84"/>
+          <p:cNvSpPr txBox="1"/>
+          <p:nvPr/>
+        </p:nvSpPr>
+        <p:spPr>
+          <a:xfrm>
+            <a:off x="685800" y="2752344"/>
+            <a:ext cx="3474720" cy="256032"/>
+          </a:xfrm>
+          <a:prstGeom prst="rect">
+            <a:avLst/>
+          </a:prstGeom>
+          <a:noFill/>
+        </p:spPr>
+        <p:txBody>
+          <a:bodyPr wrap="square">
+            <a:spAutoFit/>
+          </a:bodyPr>
+          <a:lstStyle/>
+          <a:p>
+            <a:pPr algn="l"/>
+            <a:r>
+              <a:rPr sz="1000" b="0" i="0">
+                <a:solidFill>
+                  <a:srgbClr val="94A3B8"/>
+                </a:solidFill>
+              </a:rPr>
+              <a:t>Nav bar, route loading, active link</a:t>
+            </a:r>
+          </a:p>
+        </p:txBody>
+      </p:sp>
+      <p:sp>
+        <p:nvSpPr>
+          <p:cNvPr id="86" name="Rectangle 85"/>
+          <p:cNvSpPr/>
+          <p:nvPr/>
+        </p:nvSpPr>
+        <p:spPr>
+          <a:xfrm>
+            <a:off x="4434840" y="2423160"/>
+            <a:ext cx="3749039" cy="640080"/>
+          </a:xfrm>
+          <a:prstGeom prst="rect">
+            <a:avLst/>
+          </a:prstGeom>
+          <a:solidFill>
+            <a:srgbClr val="0F172A"/>
+          </a:solidFill>
+          <a:ln w="9525">
+            <a:solidFill>
+              <a:srgbClr val="1E293B"/>
+            </a:solidFill>
+          </a:ln>
+        </p:spPr>
+        <p:style>
+          <a:lnRef idx="1">
+            <a:schemeClr val="accent1"/>
+          </a:lnRef>
+          <a:fillRef idx="3">
+            <a:schemeClr val="accent1"/>
+          </a:fillRef>
+          <a:effectRef idx="2">
+            <a:schemeClr val="accent1"/>
+          </a:effectRef>
+          <a:fontRef idx="minor">
+            <a:schemeClr val="lt1"/>
+          </a:fontRef>
+        </p:style>
+        <p:txBody>
+          <a:bodyPr rtlCol="0" anchor="ctr"/>
+          <a:lstStyle/>
+          <a:p>
+            <a:pPr algn="ctr"/>
+            <a:endParaRPr/>
+          </a:p>
+        </p:txBody>
+      </p:sp>
+      <p:sp>
+        <p:nvSpPr>
+          <p:cNvPr id="87" name="TextBox 86"/>
+          <p:cNvSpPr txBox="1"/>
+          <p:nvPr/>
+        </p:nvSpPr>
+        <p:spPr>
+          <a:xfrm>
+            <a:off x="4572000" y="2478024"/>
+            <a:ext cx="2286000" cy="274320"/>
+          </a:xfrm>
+          <a:prstGeom prst="rect">
+            <a:avLst/>
+          </a:prstGeom>
+          <a:noFill/>
+        </p:spPr>
+        <p:txBody>
+          <a:bodyPr wrap="square">
+            <a:spAutoFit/>
+          </a:bodyPr>
+          <a:lstStyle/>
+          <a:p>
+            <a:pPr algn="l"/>
+            <a:r>
+              <a:rPr sz="1100" b="1" i="0">
+                <a:solidFill>
+                  <a:srgbClr val="38BDF8"/>
+                </a:solidFill>
+              </a:rPr>
+              <a:t>filters.spec.js</a:t>
+            </a:r>
+          </a:p>
+        </p:txBody>
+      </p:sp>
+      <p:sp>
+        <p:nvSpPr>
+          <p:cNvPr id="88" name="TextBox 87"/>
+          <p:cNvSpPr txBox="1"/>
+          <p:nvPr/>
+        </p:nvSpPr>
+        <p:spPr>
+          <a:xfrm>
+            <a:off x="6995159" y="2478024"/>
+            <a:ext cx="1005840" cy="274320"/>
+          </a:xfrm>
+          <a:prstGeom prst="rect">
+            <a:avLst/>
+          </a:prstGeom>
+          <a:noFill/>
+        </p:spPr>
+        <p:txBody>
+          <a:bodyPr wrap="square">
+            <a:spAutoFit/>
+          </a:bodyPr>
+          <a:lstStyle/>
+          <a:p>
+            <a:pPr algn="r"/>
+            <a:r>
+              <a:rPr sz="1100" b="1" i="0">
+                <a:solidFill>
+                  <a:srgbClr val="22C55E"/>
+                </a:solidFill>
+              </a:rPr>
+              <a:t>5 tests</a:t>
+            </a:r>
+          </a:p>
+        </p:txBody>
+      </p:sp>
+      <p:sp>
+        <p:nvSpPr>
+          <p:cNvPr id="89" name="TextBox 88"/>
+          <p:cNvSpPr txBox="1"/>
+          <p:nvPr/>
+        </p:nvSpPr>
+        <p:spPr>
+          <a:xfrm>
+            <a:off x="4572000" y="2752344"/>
+            <a:ext cx="3474720" cy="256032"/>
+          </a:xfrm>
+          <a:prstGeom prst="rect">
+            <a:avLst/>
+          </a:prstGeom>
+          <a:noFill/>
+        </p:spPr>
+        <p:txBody>
+          <a:bodyPr wrap="square">
+            <a:spAutoFit/>
+          </a:bodyPr>
+          <a:lstStyle/>
+          <a:p>
+            <a:pPr algn="l"/>
+            <a:r>
+              <a:rPr sz="1000" b="0" i="0">
+                <a:solidFill>
+                  <a:srgbClr val="94A3B8"/>
+                </a:solidFill>
+              </a:rPr>
+              <a:t>All 4 controls, options, reset</a:t>
+            </a:r>
+          </a:p>
+        </p:txBody>
+      </p:sp>
+      <p:sp>
+        <p:nvSpPr>
+          <p:cNvPr id="90" name="Rectangle 89"/>
+          <p:cNvSpPr/>
+          <p:nvPr/>
+        </p:nvSpPr>
+        <p:spPr>
+          <a:xfrm>
+            <a:off x="8321040" y="2423160"/>
+            <a:ext cx="3749039" cy="640080"/>
+          </a:xfrm>
+          <a:prstGeom prst="rect">
+            <a:avLst/>
+          </a:prstGeom>
+          <a:solidFill>
+            <a:srgbClr val="0F172A"/>
+          </a:solidFill>
+          <a:ln w="9525">
+            <a:solidFill>
+              <a:srgbClr val="1E293B"/>
+            </a:solidFill>
+          </a:ln>
+        </p:spPr>
+        <p:style>
+          <a:lnRef idx="1">
+            <a:schemeClr val="accent1"/>
+          </a:lnRef>
+          <a:fillRef idx="3">
+            <a:schemeClr val="accent1"/>
+          </a:fillRef>
+          <a:effectRef idx="2">
+            <a:schemeClr val="accent1"/>
+          </a:effectRef>
+          <a:fontRef idx="minor">
+            <a:schemeClr val="lt1"/>
+          </a:fontRef>
+        </p:style>
+        <p:txBody>
+          <a:bodyPr rtlCol="0" anchor="ctr"/>
+          <a:lstStyle/>
+          <a:p>
+            <a:pPr algn="ctr"/>
+            <a:endParaRPr/>
+          </a:p>
+        </p:txBody>
+      </p:sp>
+      <p:sp>
+        <p:nvSpPr>
+          <p:cNvPr id="91" name="TextBox 90"/>
+          <p:cNvSpPr txBox="1"/>
+          <p:nvPr/>
+        </p:nvSpPr>
+        <p:spPr>
+          <a:xfrm>
+            <a:off x="8458200" y="2478024"/>
+            <a:ext cx="2286000" cy="274320"/>
+          </a:xfrm>
+          <a:prstGeom prst="rect">
+            <a:avLst/>
+          </a:prstGeom>
+          <a:noFill/>
+        </p:spPr>
+        <p:txBody>
+          <a:bodyPr wrap="square">
+            <a:spAutoFit/>
+          </a:bodyPr>
+          <a:lstStyle/>
+          <a:p>
+            <a:pPr algn="l"/>
+            <a:r>
+              <a:rPr sz="1100" b="1" i="0">
+                <a:solidFill>
+                  <a:srgbClr val="38BDF8"/>
+                </a:solidFill>
+              </a:rPr>
+              <a:t>dashboard.spec.js</a:t>
+            </a:r>
+          </a:p>
+        </p:txBody>
+      </p:sp>
+      <p:sp>
+        <p:nvSpPr>
+          <p:cNvPr id="92" name="TextBox 91"/>
+          <p:cNvSpPr txBox="1"/>
+          <p:nvPr/>
+        </p:nvSpPr>
+        <p:spPr>
+          <a:xfrm>
+            <a:off x="10881359" y="2478024"/>
+            <a:ext cx="1005840" cy="274320"/>
+          </a:xfrm>
+          <a:prstGeom prst="rect">
+            <a:avLst/>
+          </a:prstGeom>
+          <a:noFill/>
+        </p:spPr>
+        <p:txBody>
+          <a:bodyPr wrap="square">
+            <a:spAutoFit/>
+          </a:bodyPr>
+          <a:lstStyle/>
+          <a:p>
+            <a:pPr algn="r"/>
+            <a:r>
+              <a:rPr sz="1100" b="1" i="0">
+                <a:solidFill>
+                  <a:srgbClr val="22C55E"/>
+                </a:solidFill>
+              </a:rPr>
+              <a:t>6 tests</a:t>
+            </a:r>
+          </a:p>
+        </p:txBody>
+      </p:sp>
+      <p:sp>
+        <p:nvSpPr>
+          <p:cNvPr id="93" name="TextBox 92"/>
+          <p:cNvSpPr txBox="1"/>
+          <p:nvPr/>
+        </p:nvSpPr>
+        <p:spPr>
+          <a:xfrm>
+            <a:off x="8458200" y="2752344"/>
+            <a:ext cx="3474720" cy="256032"/>
+          </a:xfrm>
+          <a:prstGeom prst="rect">
+            <a:avLst/>
+          </a:prstGeom>
+          <a:noFill/>
+        </p:spPr>
+        <p:txBody>
+          <a:bodyPr wrap="square">
+            <a:spAutoFit/>
+          </a:bodyPr>
+          <a:lstStyle/>
+          <a:p>
+            <a:pPr algn="l"/>
+            <a:r>
+              <a:rPr sz="1000" b="0" i="0">
+                <a:solidFill>
+                  <a:srgbClr val="94A3B8"/>
+                </a:solidFill>
+              </a:rPr>
+              <a:t>Title, KPIs, Order Health, charts, filters</a:t>
+            </a:r>
+          </a:p>
+        </p:txBody>
+      </p:sp>
+      <p:sp>
+        <p:nvSpPr>
+          <p:cNvPr id="94" name="Rectangle 93"/>
+          <p:cNvSpPr/>
+          <p:nvPr/>
+        </p:nvSpPr>
+        <p:spPr>
+          <a:xfrm>
+            <a:off x="548640" y="3172968"/>
+            <a:ext cx="3749039" cy="640080"/>
+          </a:xfrm>
+          <a:prstGeom prst="rect">
+            <a:avLst/>
+          </a:prstGeom>
+          <a:solidFill>
+            <a:srgbClr val="0F172A"/>
+          </a:solidFill>
+          <a:ln w="9525">
+            <a:solidFill>
+              <a:srgbClr val="1E293B"/>
+            </a:solidFill>
+          </a:ln>
+        </p:spPr>
+        <p:style>
+          <a:lnRef idx="1">
+            <a:schemeClr val="accent1"/>
+          </a:lnRef>
+          <a:fillRef idx="3">
+            <a:schemeClr val="accent1"/>
+          </a:fillRef>
+          <a:effectRef idx="2">
+            <a:schemeClr val="accent1"/>
+          </a:effectRef>
+          <a:fontRef idx="minor">
+            <a:schemeClr val="lt1"/>
+          </a:fontRef>
+        </p:style>
+        <p:txBody>
+          <a:bodyPr rtlCol="0" anchor="ctr"/>
+          <a:lstStyle/>
+          <a:p>
+            <a:pPr algn="ctr"/>
+            <a:endParaRPr/>
+          </a:p>
+        </p:txBody>
+      </p:sp>
+      <p:sp>
+        <p:nvSpPr>
+          <p:cNvPr id="95" name="TextBox 94"/>
+          <p:cNvSpPr txBox="1"/>
+          <p:nvPr/>
+        </p:nvSpPr>
+        <p:spPr>
+          <a:xfrm>
+            <a:off x="685800" y="3227832"/>
+            <a:ext cx="2286000" cy="274320"/>
+          </a:xfrm>
+          <a:prstGeom prst="rect">
+            <a:avLst/>
+          </a:prstGeom>
+          <a:noFill/>
+        </p:spPr>
+        <p:txBody>
+          <a:bodyPr wrap="square">
+            <a:spAutoFit/>
+          </a:bodyPr>
+          <a:lstStyle/>
+          <a:p>
+            <a:pPr algn="l"/>
+            <a:r>
+              <a:rPr sz="1100" b="1" i="0">
+                <a:solidFill>
+                  <a:srgbClr val="38BDF8"/>
+                </a:solidFill>
+              </a:rPr>
+              <a:t>inventory.spec.js</a:t>
+            </a:r>
+          </a:p>
+        </p:txBody>
+      </p:sp>
+      <p:sp>
+        <p:nvSpPr>
+          <p:cNvPr id="96" name="TextBox 95"/>
+          <p:cNvSpPr txBox="1"/>
+          <p:nvPr/>
+        </p:nvSpPr>
+        <p:spPr>
+          <a:xfrm>
+            <a:off x="3108960" y="3227832"/>
+            <a:ext cx="1005840" cy="274320"/>
+          </a:xfrm>
+          <a:prstGeom prst="rect">
+            <a:avLst/>
+          </a:prstGeom>
+          <a:noFill/>
+        </p:spPr>
+        <p:txBody>
+          <a:bodyPr wrap="square">
+            <a:spAutoFit/>
+          </a:bodyPr>
+          <a:lstStyle/>
+          <a:p>
+            <a:pPr algn="r"/>
+            <a:r>
+              <a:rPr sz="1100" b="1" i="0">
+                <a:solidFill>
+                  <a:srgbClr val="22C55E"/>
+                </a:solidFill>
+              </a:rPr>
+              <a:t>6 tests</a:t>
+            </a:r>
+          </a:p>
+        </p:txBody>
+      </p:sp>
+      <p:sp>
+        <p:nvSpPr>
+          <p:cNvPr id="97" name="TextBox 96"/>
+          <p:cNvSpPr txBox="1"/>
+          <p:nvPr/>
+        </p:nvSpPr>
+        <p:spPr>
+          <a:xfrm>
+            <a:off x="685800" y="3502151"/>
+            <a:ext cx="3474720" cy="256032"/>
+          </a:xfrm>
+          <a:prstGeom prst="rect">
+            <a:avLst/>
+          </a:prstGeom>
+          <a:noFill/>
+        </p:spPr>
+        <p:txBody>
+          <a:bodyPr wrap="square">
+            <a:spAutoFit/>
+          </a:bodyPr>
+          <a:lstStyle/>
+          <a:p>
+            <a:pPr algn="l"/>
+            <a:r>
+              <a:rPr sz="1000" b="0" i="0">
+                <a:solidFill>
+                  <a:srgbClr val="94A3B8"/>
+                </a:solidFill>
+              </a:rPr>
+              <a:t>Table, columns, Location/Category filters</a:t>
+            </a:r>
+          </a:p>
+        </p:txBody>
+      </p:sp>
+      <p:sp>
+        <p:nvSpPr>
+          <p:cNvPr id="98" name="Rectangle 97"/>
+          <p:cNvSpPr/>
+          <p:nvPr/>
+        </p:nvSpPr>
+        <p:spPr>
+          <a:xfrm>
+            <a:off x="4434840" y="3172968"/>
+            <a:ext cx="3749039" cy="640080"/>
+          </a:xfrm>
+          <a:prstGeom prst="rect">
+            <a:avLst/>
+          </a:prstGeom>
+          <a:solidFill>
+            <a:srgbClr val="0F172A"/>
+          </a:solidFill>
+          <a:ln w="9525">
+            <a:solidFill>
+              <a:srgbClr val="1E293B"/>
+            </a:solidFill>
+          </a:ln>
+        </p:spPr>
+        <p:style>
+          <a:lnRef idx="1">
+            <a:schemeClr val="accent1"/>
+          </a:lnRef>
+          <a:fillRef idx="3">
+            <a:schemeClr val="accent1"/>
+          </a:fillRef>
+          <a:effectRef idx="2">
+            <a:schemeClr val="accent1"/>
+          </a:effectRef>
+          <a:fontRef idx="minor">
+            <a:schemeClr val="lt1"/>
+          </a:fontRef>
+        </p:style>
+        <p:txBody>
+          <a:bodyPr rtlCol="0" anchor="ctr"/>
+          <a:lstStyle/>
+          <a:p>
+            <a:pPr algn="ctr"/>
+            <a:endParaRPr/>
+          </a:p>
+        </p:txBody>
+      </p:sp>
+      <p:sp>
+        <p:nvSpPr>
+          <p:cNvPr id="99" name="TextBox 98"/>
+          <p:cNvSpPr txBox="1"/>
+          <p:nvPr/>
+        </p:nvSpPr>
+        <p:spPr>
+          <a:xfrm>
+            <a:off x="4572000" y="3227832"/>
+            <a:ext cx="2286000" cy="274320"/>
+          </a:xfrm>
+          <a:prstGeom prst="rect">
+            <a:avLst/>
+          </a:prstGeom>
+          <a:noFill/>
+        </p:spPr>
+        <p:txBody>
+          <a:bodyPr wrap="square">
+            <a:spAutoFit/>
+          </a:bodyPr>
+          <a:lstStyle/>
+          <a:p>
+            <a:pPr algn="l"/>
+            <a:r>
+              <a:rPr sz="1100" b="1" i="0">
+                <a:solidFill>
+                  <a:srgbClr val="38BDF8"/>
+                </a:solidFill>
+              </a:rPr>
+              <a:t>orders.spec.js</a:t>
+            </a:r>
+          </a:p>
+        </p:txBody>
+      </p:sp>
+      <p:sp>
+        <p:nvSpPr>
+          <p:cNvPr id="100" name="TextBox 99"/>
+          <p:cNvSpPr txBox="1"/>
+          <p:nvPr/>
+        </p:nvSpPr>
+        <p:spPr>
+          <a:xfrm>
+            <a:off x="6995159" y="3227832"/>
+            <a:ext cx="1005840" cy="274320"/>
+          </a:xfrm>
+          <a:prstGeom prst="rect">
+            <a:avLst/>
+          </a:prstGeom>
+          <a:noFill/>
+        </p:spPr>
+        <p:txBody>
+          <a:bodyPr wrap="square">
+            <a:spAutoFit/>
+          </a:bodyPr>
+          <a:lstStyle/>
+          <a:p>
+            <a:pPr algn="r"/>
+            <a:r>
+              <a:rPr sz="1100" b="1" i="0">
+                <a:solidFill>
+                  <a:srgbClr val="22C55E"/>
+                </a:solidFill>
+              </a:rPr>
+              <a:t>5 tests</a:t>
+            </a:r>
+          </a:p>
+        </p:txBody>
+      </p:sp>
+      <p:sp>
+        <p:nvSpPr>
+          <p:cNvPr id="101" name="TextBox 100"/>
+          <p:cNvSpPr txBox="1"/>
+          <p:nvPr/>
+        </p:nvSpPr>
+        <p:spPr>
+          <a:xfrm>
+            <a:off x="4572000" y="3502151"/>
+            <a:ext cx="3474720" cy="256032"/>
+          </a:xfrm>
+          <a:prstGeom prst="rect">
+            <a:avLst/>
+          </a:prstGeom>
+          <a:noFill/>
+        </p:spPr>
+        <p:txBody>
+          <a:bodyPr wrap="square">
+            <a:spAutoFit/>
+          </a:bodyPr>
+          <a:lstStyle/>
+          <a:p>
+            <a:pPr algn="l"/>
+            <a:r>
+              <a:rPr sz="1000" b="0" i="0">
+                <a:solidFill>
+                  <a:srgbClr val="94A3B8"/>
+                </a:solidFill>
+              </a:rPr>
+              <a:t>Table, columns, Status/Location/Period filters</a:t>
+            </a:r>
+          </a:p>
+        </p:txBody>
+      </p:sp>
+      <p:sp>
+        <p:nvSpPr>
+          <p:cNvPr id="102" name="Rectangle 101"/>
+          <p:cNvSpPr/>
+          <p:nvPr/>
+        </p:nvSpPr>
+        <p:spPr>
+          <a:xfrm>
+            <a:off x="8321040" y="3172968"/>
+            <a:ext cx="3749039" cy="640080"/>
+          </a:xfrm>
+          <a:prstGeom prst="rect">
+            <a:avLst/>
+          </a:prstGeom>
+          <a:solidFill>
+            <a:srgbClr val="0F172A"/>
+          </a:solidFill>
+          <a:ln w="9525">
+            <a:solidFill>
+              <a:srgbClr val="1E293B"/>
+            </a:solidFill>
+          </a:ln>
+        </p:spPr>
+        <p:style>
+          <a:lnRef idx="1">
+            <a:schemeClr val="accent1"/>
+          </a:lnRef>
+          <a:fillRef idx="3">
+            <a:schemeClr val="accent1"/>
+          </a:fillRef>
+          <a:effectRef idx="2">
+            <a:schemeClr val="accent1"/>
+          </a:effectRef>
+          <a:fontRef idx="minor">
+            <a:schemeClr val="lt1"/>
+          </a:fontRef>
+        </p:style>
+        <p:txBody>
+          <a:bodyPr rtlCol="0" anchor="ctr"/>
+          <a:lstStyle/>
+          <a:p>
+            <a:pPr algn="ctr"/>
+            <a:endParaRPr/>
+          </a:p>
+        </p:txBody>
+      </p:sp>
+      <p:sp>
+        <p:nvSpPr>
+          <p:cNvPr id="103" name="TextBox 102"/>
+          <p:cNvSpPr txBox="1"/>
+          <p:nvPr/>
+        </p:nvSpPr>
+        <p:spPr>
+          <a:xfrm>
+            <a:off x="8458200" y="3227832"/>
+            <a:ext cx="2286000" cy="274320"/>
+          </a:xfrm>
+          <a:prstGeom prst="rect">
+            <a:avLst/>
+          </a:prstGeom>
+          <a:noFill/>
+        </p:spPr>
+        <p:txBody>
+          <a:bodyPr wrap="square">
+            <a:spAutoFit/>
+          </a:bodyPr>
+          <a:lstStyle/>
+          <a:p>
+            <a:pPr algn="l"/>
+            <a:r>
+              <a:rPr sz="1100" b="1" i="0">
+                <a:solidFill>
+                  <a:srgbClr val="38BDF8"/>
+                </a:solidFill>
+              </a:rPr>
+              <a:t>reports.spec.js</a:t>
+            </a:r>
+          </a:p>
+        </p:txBody>
+      </p:sp>
+      <p:sp>
+        <p:nvSpPr>
+          <p:cNvPr id="104" name="TextBox 103"/>
+          <p:cNvSpPr txBox="1"/>
+          <p:nvPr/>
+        </p:nvSpPr>
+        <p:spPr>
+          <a:xfrm>
+            <a:off x="10881359" y="3227832"/>
+            <a:ext cx="1005840" cy="274320"/>
+          </a:xfrm>
+          <a:prstGeom prst="rect">
+            <a:avLst/>
+          </a:prstGeom>
+          <a:noFill/>
+        </p:spPr>
+        <p:txBody>
+          <a:bodyPr wrap="square">
+            <a:spAutoFit/>
+          </a:bodyPr>
+          <a:lstStyle/>
+          <a:p>
+            <a:pPr algn="r"/>
+            <a:r>
+              <a:rPr sz="1100" b="1" i="0">
+                <a:solidFill>
+                  <a:srgbClr val="22C55E"/>
+                </a:solidFill>
+              </a:rPr>
+              <a:t>8 tests</a:t>
+            </a:r>
+          </a:p>
+        </p:txBody>
+      </p:sp>
+      <p:sp>
+        <p:nvSpPr>
+          <p:cNvPr id="105" name="TextBox 104"/>
+          <p:cNvSpPr txBox="1"/>
+          <p:nvPr/>
+        </p:nvSpPr>
+        <p:spPr>
+          <a:xfrm>
+            <a:off x="8458200" y="3502151"/>
+            <a:ext cx="3474720" cy="256032"/>
+          </a:xfrm>
+          <a:prstGeom prst="rect">
+            <a:avLst/>
+          </a:prstGeom>
+          <a:noFill/>
+        </p:spPr>
+        <p:txBody>
+          <a:bodyPr wrap="square">
+            <a:spAutoFit/>
+          </a:bodyPr>
+          <a:lstStyle/>
+          <a:p>
+            <a:pPr algn="l"/>
+            <a:r>
+              <a:rPr sz="1000" b="0" i="0">
+                <a:solidFill>
+                  <a:srgbClr val="94A3B8"/>
+                </a:solidFill>
+              </a:rPr>
+              <a:t>Quarterly table, MoM, bar chart, stats, filters</a:t>
+            </a:r>
+          </a:p>
+        </p:txBody>
+      </p:sp>
+      <p:sp>
+        <p:nvSpPr>
+          <p:cNvPr id="106" name="Rectangle 105"/>
+          <p:cNvSpPr/>
+          <p:nvPr/>
+        </p:nvSpPr>
+        <p:spPr>
+          <a:xfrm>
+            <a:off x="548640" y="3922776"/>
+            <a:ext cx="3749039" cy="640080"/>
+          </a:xfrm>
+          <a:prstGeom prst="rect">
+            <a:avLst/>
+          </a:prstGeom>
+          <a:solidFill>
+            <a:srgbClr val="0F172A"/>
+          </a:solidFill>
+          <a:ln w="9525">
+            <a:solidFill>
+              <a:srgbClr val="1E293B"/>
+            </a:solidFill>
+          </a:ln>
+        </p:spPr>
+        <p:style>
+          <a:lnRef idx="1">
+            <a:schemeClr val="accent1"/>
+          </a:lnRef>
+          <a:fillRef idx="3">
+            <a:schemeClr val="accent1"/>
+          </a:fillRef>
+          <a:effectRef idx="2">
+            <a:schemeClr val="accent1"/>
+          </a:effectRef>
+          <a:fontRef idx="minor">
+            <a:schemeClr val="lt1"/>
+          </a:fontRef>
+        </p:style>
+        <p:txBody>
+          <a:bodyPr rtlCol="0" anchor="ctr"/>
+          <a:lstStyle/>
+          <a:p>
+            <a:pPr algn="ctr"/>
+            <a:endParaRPr/>
+          </a:p>
+        </p:txBody>
+      </p:sp>
+      <p:sp>
+        <p:nvSpPr>
+          <p:cNvPr id="107" name="TextBox 106"/>
+          <p:cNvSpPr txBox="1"/>
+          <p:nvPr/>
+        </p:nvSpPr>
+        <p:spPr>
+          <a:xfrm>
+            <a:off x="685800" y="3977639"/>
+            <a:ext cx="2286000" cy="274320"/>
+          </a:xfrm>
+          <a:prstGeom prst="rect">
+            <a:avLst/>
+          </a:prstGeom>
+          <a:noFill/>
+        </p:spPr>
+        <p:txBody>
+          <a:bodyPr wrap="square">
+            <a:spAutoFit/>
+          </a:bodyPr>
+          <a:lstStyle/>
+          <a:p>
+            <a:pPr algn="l"/>
+            <a:r>
+              <a:rPr sz="1100" b="1" i="0">
+                <a:solidFill>
+                  <a:srgbClr val="38BDF8"/>
+                </a:solidFill>
+              </a:rPr>
+              <a:t>restocking.spec.js</a:t>
+            </a:r>
+          </a:p>
+        </p:txBody>
+      </p:sp>
+      <p:sp>
+        <p:nvSpPr>
+          <p:cNvPr id="108" name="TextBox 107"/>
+          <p:cNvSpPr txBox="1"/>
+          <p:nvPr/>
+        </p:nvSpPr>
+        <p:spPr>
+          <a:xfrm>
+            <a:off x="3108960" y="3977639"/>
+            <a:ext cx="1005840" cy="274320"/>
+          </a:xfrm>
+          <a:prstGeom prst="rect">
+            <a:avLst/>
+          </a:prstGeom>
+          <a:noFill/>
+        </p:spPr>
+        <p:txBody>
+          <a:bodyPr wrap="square">
+            <a:spAutoFit/>
+          </a:bodyPr>
+          <a:lstStyle/>
+          <a:p>
+            <a:pPr algn="r"/>
+            <a:r>
+              <a:rPr sz="1100" b="1" i="0">
+                <a:solidFill>
+                  <a:srgbClr val="22C55E"/>
+                </a:solidFill>
+              </a:rPr>
+              <a:t>9 tests</a:t>
+            </a:r>
+          </a:p>
+        </p:txBody>
+      </p:sp>
+      <p:sp>
+        <p:nvSpPr>
+          <p:cNvPr id="109" name="TextBox 108"/>
+          <p:cNvSpPr txBox="1"/>
+          <p:nvPr/>
+        </p:nvSpPr>
+        <p:spPr>
+          <a:xfrm>
+            <a:off x="685800" y="4251960"/>
+            <a:ext cx="3474720" cy="256032"/>
+          </a:xfrm>
+          <a:prstGeom prst="rect">
+            <a:avLst/>
+          </a:prstGeom>
+          <a:noFill/>
+        </p:spPr>
+        <p:txBody>
+          <a:bodyPr wrap="square">
+            <a:spAutoFit/>
+          </a:bodyPr>
+          <a:lstStyle/>
+          <a:p>
+            <a:pPr algn="l"/>
+            <a:r>
+              <a:rPr sz="1000" b="0" i="0">
+                <a:solidFill>
+                  <a:srgbClr val="94A3B8"/>
+                </a:solidFill>
+              </a:rPr>
+              <a:t>Budget input, stat cards, table, Status column logic</a:t>
+            </a:r>
+          </a:p>
+        </p:txBody>
+      </p:sp>
+      <p:sp>
+        <p:nvSpPr>
+          <p:cNvPr id="110" name="Rectangle 109"/>
+          <p:cNvSpPr/>
+          <p:nvPr/>
+        </p:nvSpPr>
+        <p:spPr>
+          <a:xfrm>
+            <a:off x="4434840" y="3922776"/>
+            <a:ext cx="3749039" cy="640080"/>
+          </a:xfrm>
+          <a:prstGeom prst="rect">
+            <a:avLst/>
+          </a:prstGeom>
+          <a:solidFill>
+            <a:srgbClr val="0F172A"/>
+          </a:solidFill>
+          <a:ln w="9525">
+            <a:solidFill>
+              <a:srgbClr val="1E293B"/>
+            </a:solidFill>
+          </a:ln>
+        </p:spPr>
+        <p:style>
+          <a:lnRef idx="1">
+            <a:schemeClr val="accent1"/>
+          </a:lnRef>
+          <a:fillRef idx="3">
+            <a:schemeClr val="accent1"/>
+          </a:fillRef>
+          <a:effectRef idx="2">
+            <a:schemeClr val="accent1"/>
+          </a:effectRef>
+          <a:fontRef idx="minor">
+            <a:schemeClr val="lt1"/>
+          </a:fontRef>
+        </p:style>
+        <p:txBody>
+          <a:bodyPr rtlCol="0" anchor="ctr"/>
+          <a:lstStyle/>
+          <a:p>
+            <a:pPr algn="ctr"/>
+            <a:endParaRPr/>
+          </a:p>
+        </p:txBody>
+      </p:sp>
+      <p:sp>
+        <p:nvSpPr>
+          <p:cNvPr id="111" name="TextBox 110"/>
+          <p:cNvSpPr txBox="1"/>
+          <p:nvPr/>
+        </p:nvSpPr>
+        <p:spPr>
+          <a:xfrm>
+            <a:off x="4572000" y="3977639"/>
+            <a:ext cx="2286000" cy="274320"/>
+          </a:xfrm>
+          <a:prstGeom prst="rect">
+            <a:avLst/>
+          </a:prstGeom>
+          <a:noFill/>
+        </p:spPr>
+        <p:txBody>
+          <a:bodyPr wrap="square">
+            <a:spAutoFit/>
+          </a:bodyPr>
+          <a:lstStyle/>
+          <a:p>
+            <a:pPr algn="l"/>
+            <a:r>
+              <a:rPr sz="1100" b="1" i="0">
+                <a:solidFill>
+                  <a:srgbClr val="38BDF8"/>
+                </a:solidFill>
+              </a:rPr>
+              <a:t>spending.spec.js</a:t>
+            </a:r>
+          </a:p>
+        </p:txBody>
+      </p:sp>
+      <p:sp>
+        <p:nvSpPr>
+          <p:cNvPr id="112" name="TextBox 111"/>
+          <p:cNvSpPr txBox="1"/>
+          <p:nvPr/>
+        </p:nvSpPr>
+        <p:spPr>
+          <a:xfrm>
+            <a:off x="6995159" y="3977639"/>
+            <a:ext cx="1005840" cy="274320"/>
+          </a:xfrm>
+          <a:prstGeom prst="rect">
+            <a:avLst/>
+          </a:prstGeom>
+          <a:noFill/>
+        </p:spPr>
+        <p:txBody>
+          <a:bodyPr wrap="square">
+            <a:spAutoFit/>
+          </a:bodyPr>
+          <a:lstStyle/>
+          <a:p>
+            <a:pPr algn="r"/>
+            <a:r>
+              <a:rPr sz="1100" b="1" i="0">
+                <a:solidFill>
+                  <a:srgbClr val="22C55E"/>
+                </a:solidFill>
+              </a:rPr>
+              <a:t>6 tests</a:t>
+            </a:r>
+          </a:p>
+        </p:txBody>
+      </p:sp>
+      <p:sp>
+        <p:nvSpPr>
+          <p:cNvPr id="113" name="TextBox 112"/>
+          <p:cNvSpPr txBox="1"/>
+          <p:nvPr/>
+        </p:nvSpPr>
+        <p:spPr>
+          <a:xfrm>
+            <a:off x="4572000" y="4251960"/>
+            <a:ext cx="3474720" cy="256032"/>
+          </a:xfrm>
+          <a:prstGeom prst="rect">
+            <a:avLst/>
+          </a:prstGeom>
+          <a:noFill/>
+        </p:spPr>
+        <p:txBody>
+          <a:bodyPr wrap="square">
+            <a:spAutoFit/>
+          </a:bodyPr>
+          <a:lstStyle/>
+          <a:p>
+            <a:pPr algn="l"/>
+            <a:r>
+              <a:rPr sz="1000" b="0" i="0">
+                <a:solidFill>
+                  <a:srgbClr val="94A3B8"/>
+                </a:solidFill>
+              </a:rPr>
+              <a:t>KPI cards, charts, period filter</a:t>
+            </a:r>
+          </a:p>
+        </p:txBody>
+      </p:sp>
+      <p:sp>
+        <p:nvSpPr>
+          <p:cNvPr id="114" name="Rectangle 113"/>
+          <p:cNvSpPr/>
+          <p:nvPr/>
+        </p:nvSpPr>
+        <p:spPr>
+          <a:xfrm>
+            <a:off x="8321040" y="3922776"/>
+            <a:ext cx="3749039" cy="640080"/>
+          </a:xfrm>
+          <a:prstGeom prst="rect">
+            <a:avLst/>
+          </a:prstGeom>
+          <a:solidFill>
+            <a:srgbClr val="0F172A"/>
+          </a:solidFill>
+          <a:ln w="9525">
+            <a:solidFill>
+              <a:srgbClr val="1E293B"/>
+            </a:solidFill>
+          </a:ln>
+        </p:spPr>
+        <p:style>
+          <a:lnRef idx="1">
+            <a:schemeClr val="accent1"/>
+          </a:lnRef>
+          <a:fillRef idx="3">
+            <a:schemeClr val="accent1"/>
+          </a:fillRef>
+          <a:effectRef idx="2">
+            <a:schemeClr val="accent1"/>
+          </a:effectRef>
+          <a:fontRef idx="minor">
+            <a:schemeClr val="lt1"/>
+          </a:fontRef>
+        </p:style>
+        <p:txBody>
+          <a:bodyPr rtlCol="0" anchor="ctr"/>
+          <a:lstStyle/>
+          <a:p>
+            <a:pPr algn="ctr"/>
+            <a:endParaRPr/>
+          </a:p>
+        </p:txBody>
+      </p:sp>
+      <p:sp>
+        <p:nvSpPr>
+          <p:cNvPr id="115" name="TextBox 114"/>
+          <p:cNvSpPr txBox="1"/>
+          <p:nvPr/>
+        </p:nvSpPr>
+        <p:spPr>
+          <a:xfrm>
+            <a:off x="8458200" y="3977639"/>
+            <a:ext cx="2286000" cy="274320"/>
+          </a:xfrm>
+          <a:prstGeom prst="rect">
+            <a:avLst/>
+          </a:prstGeom>
+          <a:noFill/>
+        </p:spPr>
+        <p:txBody>
+          <a:bodyPr wrap="square">
+            <a:spAutoFit/>
+          </a:bodyPr>
+          <a:lstStyle/>
+          <a:p>
+            <a:pPr algn="l"/>
+            <a:r>
+              <a:rPr sz="1100" b="1" i="0">
+                <a:solidFill>
+                  <a:srgbClr val="38BDF8"/>
+                </a:solidFill>
+              </a:rPr>
+              <a:t>demand.spec.js</a:t>
+            </a:r>
+          </a:p>
+        </p:txBody>
+      </p:sp>
+      <p:sp>
+        <p:nvSpPr>
+          <p:cNvPr id="116" name="TextBox 115"/>
+          <p:cNvSpPr txBox="1"/>
+          <p:nvPr/>
+        </p:nvSpPr>
+        <p:spPr>
+          <a:xfrm>
+            <a:off x="10881359" y="3977639"/>
+            <a:ext cx="1005840" cy="274320"/>
+          </a:xfrm>
+          <a:prstGeom prst="rect">
+            <a:avLst/>
+          </a:prstGeom>
+          <a:noFill/>
+        </p:spPr>
+        <p:txBody>
+          <a:bodyPr wrap="square">
+            <a:spAutoFit/>
+          </a:bodyPr>
+          <a:lstStyle/>
+          <a:p>
+            <a:pPr algn="r"/>
+            <a:r>
+              <a:rPr sz="1100" b="1" i="0">
+                <a:solidFill>
+                  <a:srgbClr val="22C55E"/>
+                </a:solidFill>
+              </a:rPr>
+              <a:t>7 tests</a:t>
+            </a:r>
+          </a:p>
+        </p:txBody>
+      </p:sp>
+      <p:sp>
+        <p:nvSpPr>
+          <p:cNvPr id="117" name="TextBox 116"/>
           <p:cNvSpPr txBox="1"/>
           <p:nvPr/>
         </p:nvSpPr>
@@ -7444,7 +9813,7 @@
 </file>
 
 <file path=ppt/slides/slide6.xml><?xml version="1.0" encoding="utf-8"?>
-<p:sld xmlns:a="http://schemas.openxmlformats.org/drawingml/2006/main" xmlns:p="http://schemas.openxmlformats.org/presentationml/2006/main" xmlns:r="http://schemas.openxmlformats.org/officeDocument/2006/relationships">
+<p:sld xmlns:a="http://schemas.openxmlformats.org/drawingml/2006/main" xmlns:r="http://schemas.openxmlformats.org/officeDocument/2006/relationships" xmlns:p="http://schemas.openxmlformats.org/presentationml/2006/main">
   <p:cSld>
     <p:bg>
       <p:bgPr>
@@ -7460,7 +9829,14 @@
         <p:cNvGrpSpPr/>
         <p:nvPr/>
       </p:nvGrpSpPr>
-      <p:grpSpPr/>
+      <p:grpSpPr>
+        <a:xfrm>
+          <a:off x="0" y="0"/>
+          <a:ext cx="0" cy="0"/>
+          <a:chOff x="0" y="0"/>
+          <a:chExt cx="0" cy="0"/>
+        </a:xfrm>
+      </p:grpSpPr>
       <p:sp>
         <p:nvSpPr>
           <p:cNvPr id="2" name="Rectangle 1"/>
@@ -7501,6 +9877,7 @@
           <a:lstStyle/>
           <a:p>
             <a:pPr algn="ctr"/>
+            <a:endParaRPr/>
           </a:p>
         </p:txBody>
       </p:sp>
@@ -7528,7 +9905,7 @@
           <a:p>
             <a:pPr algn="ctr"/>
             <a:r>
-              <a:rPr sz="1000" b="1" i="0">
+              <a:rPr lang="it-IT" sz="1000" b="1" i="0">
                 <a:solidFill>
                   <a:srgbClr val="22C55E"/>
                 </a:solidFill>
@@ -7547,22 +9924,22 @@
         <p:spPr>
           <a:xfrm>
             <a:off x="548640" y="822960"/>
-            <a:ext cx="9144000" cy="457200"/>
-          </a:xfrm>
-          <a:prstGeom prst="rect">
-            <a:avLst/>
-          </a:prstGeom>
-          <a:noFill/>
-        </p:spPr>
-        <p:txBody>
-          <a:bodyPr wrap="square">
-            <a:spAutoFit/>
-          </a:bodyPr>
-          <a:lstStyle/>
-          <a:p>
-            <a:pPr algn="l"/>
-            <a:r>
-              <a:rPr sz="1100" b="1" i="0">
+            <a:ext cx="9144000" cy="261610"/>
+          </a:xfrm>
+          <a:prstGeom prst="rect">
+            <a:avLst/>
+          </a:prstGeom>
+          <a:noFill/>
+        </p:spPr>
+        <p:txBody>
+          <a:bodyPr wrap="square">
+            <a:spAutoFit/>
+          </a:bodyPr>
+          <a:lstStyle/>
+          <a:p>
+            <a:pPr algn="l"/>
+            <a:r>
+              <a:rPr lang="it-IT" sz="1100" b="1" i="0">
                 <a:solidFill>
                   <a:srgbClr val="38BDF8"/>
                 </a:solidFill>
@@ -7581,22 +9958,22 @@
         <p:spPr>
           <a:xfrm>
             <a:off x="548640" y="1234440"/>
-            <a:ext cx="10058400" cy="914400"/>
-          </a:xfrm>
-          <a:prstGeom prst="rect">
-            <a:avLst/>
-          </a:prstGeom>
-          <a:noFill/>
-        </p:spPr>
-        <p:txBody>
-          <a:bodyPr wrap="square">
-            <a:spAutoFit/>
-          </a:bodyPr>
-          <a:lstStyle/>
-          <a:p>
-            <a:pPr algn="l"/>
-            <a:r>
-              <a:rPr sz="3200" b="1" i="0">
+            <a:ext cx="10058400" cy="1077218"/>
+          </a:xfrm>
+          <a:prstGeom prst="rect">
+            <a:avLst/>
+          </a:prstGeom>
+          <a:noFill/>
+        </p:spPr>
+        <p:txBody>
+          <a:bodyPr wrap="square">
+            <a:spAutoFit/>
+          </a:bodyPr>
+          <a:lstStyle/>
+          <a:p>
+            <a:pPr algn="l"/>
+            <a:r>
+              <a:rPr lang="en-US" sz="3200" b="1" i="0">
                 <a:solidFill>
                   <a:srgbClr val="F8FAFC"/>
                 </a:solidFill>
@@ -7649,6 +10026,7 @@
           <a:lstStyle/>
           <a:p>
             <a:pPr algn="ctr"/>
+            <a:endParaRPr/>
           </a:p>
         </p:txBody>
       </p:sp>
@@ -7762,6 +10140,7 @@
           <a:lstStyle/>
           <a:p>
             <a:pPr algn="ctr"/>
+            <a:endParaRPr/>
           </a:p>
         </p:txBody>
       </p:sp>
@@ -7875,6 +10254,7 @@
           <a:lstStyle/>
           <a:p>
             <a:pPr algn="ctr"/>
+            <a:endParaRPr/>
           </a:p>
         </p:txBody>
       </p:sp>
@@ -7988,6 +10368,7 @@
           <a:lstStyle/>
           <a:p>
             <a:pPr algn="ctr"/>
+            <a:endParaRPr/>
           </a:p>
         </p:txBody>
       </p:sp>
@@ -8055,6 +10436,301 @@
                 </a:solidFill>
               </a:rPr>
               <a:t>How to add endpoints, add views, replace JSON with a real DB, run the Playwright suite.</a:t>
+            </a:r>
+          </a:p>
+        </p:txBody>
+      </p:sp>
+      <p:sp>
+        <p:nvSpPr>
+          <p:cNvPr id="23" name="TextBox 22"/>
+          <p:cNvSpPr txBox="1"/>
+          <p:nvPr/>
+        </p:nvSpPr>
+        <p:spPr>
+          <a:xfrm>
+            <a:off x="731520" y="2377440"/>
+            <a:ext cx="5029200" cy="365760"/>
+          </a:xfrm>
+          <a:prstGeom prst="rect">
+            <a:avLst/>
+          </a:prstGeom>
+          <a:noFill/>
+        </p:spPr>
+        <p:txBody>
+          <a:bodyPr wrap="square">
+            <a:spAutoFit/>
+          </a:bodyPr>
+          <a:lstStyle/>
+          <a:p>
+            <a:pPr algn="l"/>
+            <a:r>
+              <a:rPr sz="1400" b="1" i="0">
+                <a:solidFill>
+                  <a:srgbClr val="38BDF8"/>
+                </a:solidFill>
+              </a:rPr>
+              <a:t>R4 — What we're building</a:t>
+            </a:r>
+          </a:p>
+        </p:txBody>
+      </p:sp>
+      <p:sp>
+        <p:nvSpPr>
+          <p:cNvPr id="24" name="TextBox 23"/>
+          <p:cNvSpPr txBox="1"/>
+          <p:nvPr/>
+        </p:nvSpPr>
+        <p:spPr>
+          <a:xfrm>
+            <a:off x="731520" y="2834640"/>
+            <a:ext cx="5029200" cy="2560320"/>
+          </a:xfrm>
+          <a:prstGeom prst="rect">
+            <a:avLst/>
+          </a:prstGeom>
+          <a:noFill/>
+        </p:spPr>
+        <p:txBody>
+          <a:bodyPr wrap="square">
+            <a:spAutoFit/>
+          </a:bodyPr>
+          <a:lstStyle/>
+          <a:p>
+            <a:pPr>
+              <a:spcBef>
+                <a:spcPts val="700"/>
+              </a:spcBef>
+            </a:pPr>
+            <a:r>
+              <a:rPr sz="1300">
+                <a:solidFill>
+                  <a:srgbClr val="CBD5E1"/>
+                </a:solidFill>
+              </a:rPr>
+              <a:t>→  HTML architecture diagram (component map + data flow)</a:t>
+            </a:r>
+          </a:p>
+          <a:p>
+            <a:pPr>
+              <a:spcBef>
+                <a:spcPts val="700"/>
+              </a:spcBef>
+            </a:pPr>
+            <a:r>
+              <a:rPr sz="1300">
+                <a:solidFill>
+                  <a:srgbClr val="CBD5E1"/>
+                </a:solidFill>
+              </a:rPr>
+              <a:t>→  API endpoint reference with request/response shapes</a:t>
+            </a:r>
+          </a:p>
+          <a:p>
+            <a:pPr>
+              <a:spcBef>
+                <a:spcPts val="700"/>
+              </a:spcBef>
+            </a:pPr>
+            <a:r>
+              <a:rPr sz="1300">
+                <a:solidFill>
+                  <a:srgbClr val="CBD5E1"/>
+                </a:solidFill>
+              </a:rPr>
+              <a:t>→  Mock-data layer documentation for Meridian IT</a:t>
+            </a:r>
+          </a:p>
+          <a:p>
+            <a:pPr>
+              <a:spcBef>
+                <a:spcPts val="700"/>
+              </a:spcBef>
+            </a:pPr>
+            <a:r>
+              <a:rPr sz="1300">
+                <a:solidFill>
+                  <a:srgbClr val="CBD5E1"/>
+                </a:solidFill>
+              </a:rPr>
+              <a:t>→  Handoff notes: how to extend the app post-engagement</a:t>
+            </a:r>
+          </a:p>
+        </p:txBody>
+      </p:sp>
+      <p:sp>
+        <p:nvSpPr>
+          <p:cNvPr id="25" name="Rectangle 24"/>
+          <p:cNvSpPr/>
+          <p:nvPr/>
+        </p:nvSpPr>
+        <p:spPr>
+          <a:xfrm>
+            <a:off x="6217920" y="2240280"/>
+            <a:ext cx="5394960" cy="3383280"/>
+          </a:xfrm>
+          <a:prstGeom prst="rect">
+            <a:avLst/>
+          </a:prstGeom>
+          <a:solidFill>
+            <a:srgbClr val="1E293B"/>
+          </a:solidFill>
+          <a:ln w="9525">
+            <a:solidFill>
+              <a:srgbClr val="334155"/>
+            </a:solidFill>
+          </a:ln>
+        </p:spPr>
+        <p:style>
+          <a:lnRef idx="1">
+            <a:schemeClr val="accent1"/>
+          </a:lnRef>
+          <a:fillRef idx="3">
+            <a:schemeClr val="accent1"/>
+          </a:fillRef>
+          <a:effectRef idx="2">
+            <a:schemeClr val="accent1"/>
+          </a:effectRef>
+          <a:fontRef idx="minor">
+            <a:schemeClr val="lt1"/>
+          </a:fontRef>
+        </p:style>
+        <p:txBody>
+          <a:bodyPr rtlCol="0" anchor="ctr"/>
+          <a:lstStyle/>
+          <a:p>
+            <a:pPr algn="ctr"/>
+            <a:endParaRPr/>
+          </a:p>
+        </p:txBody>
+      </p:sp>
+      <p:sp>
+        <p:nvSpPr>
+          <p:cNvPr id="26" name="TextBox 25"/>
+          <p:cNvSpPr txBox="1"/>
+          <p:nvPr/>
+        </p:nvSpPr>
+        <p:spPr>
+          <a:xfrm>
+            <a:off x="6400800" y="2377440"/>
+            <a:ext cx="5029200" cy="365760"/>
+          </a:xfrm>
+          <a:prstGeom prst="rect">
+            <a:avLst/>
+          </a:prstGeom>
+          <a:noFill/>
+        </p:spPr>
+        <p:txBody>
+          <a:bodyPr wrap="square">
+            <a:spAutoFit/>
+          </a:bodyPr>
+          <a:lstStyle/>
+          <a:p>
+            <a:pPr algn="l"/>
+            <a:r>
+              <a:rPr sz="1400" b="1" i="0">
+                <a:solidFill>
+                  <a:srgbClr val="38BDF8"/>
+                </a:solidFill>
+              </a:rPr>
+              <a:t>Remaining work + optional</a:t>
+            </a:r>
+          </a:p>
+        </p:txBody>
+      </p:sp>
+      <p:sp>
+        <p:nvSpPr>
+          <p:cNvPr id="27" name="TextBox 26"/>
+          <p:cNvSpPr txBox="1"/>
+          <p:nvPr/>
+        </p:nvSpPr>
+        <p:spPr>
+          <a:xfrm>
+            <a:off x="6400800" y="2834640"/>
+            <a:ext cx="5029200" cy="2560320"/>
+          </a:xfrm>
+          <a:prstGeom prst="rect">
+            <a:avLst/>
+          </a:prstGeom>
+          <a:noFill/>
+        </p:spPr>
+        <p:txBody>
+          <a:bodyPr wrap="square">
+            <a:spAutoFit/>
+          </a:bodyPr>
+          <a:lstStyle/>
+          <a:p>
+            <a:pPr>
+              <a:spcBef>
+                <a:spcPts val="700"/>
+              </a:spcBef>
+            </a:pPr>
+            <a:r>
+              <a:rPr sz="1300">
+                <a:solidFill>
+                  <a:srgbClr val="CBD5E1"/>
+                </a:solidFill>
+              </a:rPr>
+              <a:t>→  R4: Architecture HTML + handoff doc  (next)</a:t>
+            </a:r>
+          </a:p>
+          <a:p>
+            <a:pPr>
+              <a:spcBef>
+                <a:spcPts val="700"/>
+              </a:spcBef>
+            </a:pPr>
+            <a:r>
+              <a:rPr sz="1300">
+                <a:solidFill>
+                  <a:srgbClr val="CBD5E1"/>
+                </a:solidFill>
+              </a:rPr>
+              <a:t>→  D1: UI refresh  (optional, weeks 11–12)</a:t>
+            </a:r>
+          </a:p>
+          <a:p>
+            <a:pPr>
+              <a:spcBef>
+                <a:spcPts val="700"/>
+              </a:spcBef>
+            </a:pPr>
+            <a:r>
+              <a:rPr sz="1300">
+                <a:solidFill>
+                  <a:srgbClr val="CBD5E1"/>
+                </a:solidFill>
+              </a:rPr>
+              <a:t>→  D2: Full i18n expansion  (optional)</a:t>
+            </a:r>
+          </a:p>
+          <a:p>
+            <a:pPr>
+              <a:spcBef>
+                <a:spcPts val="700"/>
+              </a:spcBef>
+            </a:pPr>
+            <a:r>
+              <a:rPr sz="1300">
+                <a:solidFill>
+                  <a:srgbClr val="CBD5E1"/>
+                </a:solidFill>
+              </a:rPr>
+              <a:t>→  D3: Dark mode prototype on branch  (optional)</a:t>
+            </a:r>
+          </a:p>
+          <a:p>
+            <a:pPr>
+              <a:spcBef>
+                <a:spcPts val="700"/>
+              </a:spcBef>
+            </a:pPr>
+            <a:r>
+              <a:rPr sz="1300">
+                <a:solidFill>
+                  <a:srgbClr val="CBD5E1"/>
+                </a:solidFill>
+              </a:rPr>
+              <a:t>→  PR merge + Meridian IT walkthrough</a:t>
             </a:r>
           </a:p>
         </p:txBody>
@@ -8068,7 +10744,7 @@
 </file>
 
 <file path=ppt/slides/slide7.xml><?xml version="1.0" encoding="utf-8"?>
-<p:sld xmlns:a="http://schemas.openxmlformats.org/drawingml/2006/main" xmlns:p="http://schemas.openxmlformats.org/presentationml/2006/main" xmlns:r="http://schemas.openxmlformats.org/officeDocument/2006/relationships">
+<p:sld xmlns:a="http://schemas.openxmlformats.org/drawingml/2006/main" xmlns:r="http://schemas.openxmlformats.org/officeDocument/2006/relationships" xmlns:p="http://schemas.openxmlformats.org/presentationml/2006/main">
   <p:cSld>
     <p:bg>
       <p:bgPr>
@@ -8084,7 +10760,14 @@
         <p:cNvGrpSpPr/>
         <p:nvPr/>
       </p:nvGrpSpPr>
-      <p:grpSpPr/>
+      <p:grpSpPr>
+        <a:xfrm>
+          <a:off x="0" y="0"/>
+          <a:ext cx="0" cy="0"/>
+          <a:chOff x="0" y="0"/>
+          <a:chExt cx="0" cy="0"/>
+        </a:xfrm>
+      </p:grpSpPr>
       <p:sp>
         <p:nvSpPr>
           <p:cNvPr id="2" name="TextBox 1"/>
@@ -8265,6 +10948,7 @@
           <a:lstStyle/>
           <a:p>
             <a:pPr algn="ctr"/>
+            <a:endParaRPr/>
           </a:p>
         </p:txBody>
       </p:sp>
@@ -8446,6 +11130,7 @@
           <a:lstStyle/>
           <a:p>
             <a:pPr algn="ctr"/>
+            <a:endParaRPr/>
           </a:p>
         </p:txBody>
       </p:sp>

</xml_diff>

<commit_message>
Update progress deck: add PR #29 reference throughout
Co-Authored-By: Claude Sonnet 4.6 <noreply@anthropic.com>
</commit_message>
<xml_diff>
--- a/proposal/progress-report.pptx
+++ b/proposal/progress-report.pptx
@@ -3306,7 +3306,7 @@
                   <a:srgbClr val="475569"/>
                 </a:solidFill>
               </a:rPr>
-              <a:t>April 27, 2026  ·  branch: feature/meridian-engagement</a:t>
+              <a:t>April 27, 2026  ·  branch: feature/meridian-engagement  ·  PR #29</a:t>
             </a:r>
           </a:p>
         </p:txBody>
@@ -4074,7 +4074,7 @@
                   <a:srgbClr val="94A3B8"/>
                 </a:solidFill>
               </a:rPr>
-              <a:t>Repo:</a:t>
+              <a:t>PR:</a:t>
             </a:r>
           </a:p>
         </p:txBody>
@@ -4108,6 +4108,74 @@
                   <a:srgbClr val="CBD5E1"/>
                 </a:solidFill>
               </a:rPr>
+              <a:t>github.com/lindsey-anthropic/meridian-workshop/pull/29</a:t>
+            </a:r>
+          </a:p>
+        </p:txBody>
+      </p:sp>
+      <p:sp>
+        <p:nvSpPr>
+          <p:cNvPr id="24" name="TextBox 23"/>
+          <p:cNvSpPr txBox="1"/>
+          <p:nvPr/>
+        </p:nvSpPr>
+        <p:spPr>
+          <a:xfrm>
+            <a:off x="731520" y="6199632"/>
+            <a:ext cx="1097280" cy="320040"/>
+          </a:xfrm>
+          <a:prstGeom prst="rect">
+            <a:avLst/>
+          </a:prstGeom>
+          <a:noFill/>
+        </p:spPr>
+        <p:txBody>
+          <a:bodyPr wrap="square">
+            <a:spAutoFit/>
+          </a:bodyPr>
+          <a:lstStyle/>
+          <a:p>
+            <a:pPr algn="l"/>
+            <a:r>
+              <a:rPr sz="1200" b="1" i="0">
+                <a:solidFill>
+                  <a:srgbClr val="94A3B8"/>
+                </a:solidFill>
+              </a:rPr>
+              <a:t>Repo:</a:t>
+            </a:r>
+          </a:p>
+        </p:txBody>
+      </p:sp>
+      <p:sp>
+        <p:nvSpPr>
+          <p:cNvPr id="25" name="TextBox 24"/>
+          <p:cNvSpPr txBox="1"/>
+          <p:nvPr/>
+        </p:nvSpPr>
+        <p:spPr>
+          <a:xfrm>
+            <a:off x="1965960" y="6199632"/>
+            <a:ext cx="8961120" cy="411480"/>
+          </a:xfrm>
+          <a:prstGeom prst="rect">
+            <a:avLst/>
+          </a:prstGeom>
+          <a:noFill/>
+        </p:spPr>
+        <p:txBody>
+          <a:bodyPr wrap="square">
+            <a:spAutoFit/>
+          </a:bodyPr>
+          <a:lstStyle/>
+          <a:p>
+            <a:pPr algn="l"/>
+            <a:r>
+              <a:rPr sz="1200" b="0" i="0">
+                <a:solidFill>
+                  <a:srgbClr val="CBD5E1"/>
+                </a:solidFill>
+              </a:rPr>
               <a:t>github.com/lindsey-anthropic/meridian-workshop</a:t>
             </a:r>
           </a:p>
@@ -4115,7 +4183,7 @@
       </p:sp>
       <p:sp>
         <p:nvSpPr>
-          <p:cNvPr id="24" name="TextBox 23"/>
+          <p:cNvPr id="26" name="TextBox 25"/>
           <p:cNvSpPr txBox="1"/>
           <p:nvPr/>
         </p:nvSpPr>
@@ -4142,7 +4210,7 @@
                   <a:srgbClr val="475569"/>
                 </a:solidFill>
               </a:rPr>
-              <a:t>RFP #MC-2026-0417  ·  April 27, 2026</a:t>
+              <a:t>RFP #MC-2026-0417  ·  PR #29  ·  April 27, 2026</a:t>
             </a:r>
           </a:p>
         </p:txBody>
@@ -9877,7 +9945,7 @@
                   <a:srgbClr val="475569"/>
                 </a:solidFill>
               </a:rPr>
-              <a:t>branch: feature/meridian-engagement  ·  RFP #MC-2026-0417  ·  April 27, 2026</a:t>
+              <a:t>branch: feature/meridian-engagement  ·  PR #29  ·  RFP #MC-2026-0417  ·  April 27, 2026</a:t>
             </a:r>
           </a:p>
         </p:txBody>
@@ -10535,7 +10603,7 @@
                   <a:srgbClr val="475569"/>
                 </a:solidFill>
               </a:rPr>
-              <a:t>branch: feature/meridian-engagement  ·  commit: 272787c</a:t>
+              <a:t>branch: feature/meridian-engagement  ·  PR #29  ·  commit: 272787c</a:t>
             </a:r>
           </a:p>
         </p:txBody>
@@ -11390,7 +11458,7 @@
                   <a:srgbClr val="475569"/>
                 </a:solidFill>
               </a:rPr>
-              <a:t>branch: feature/meridian-engagement  ·  commit: 272787c</a:t>
+              <a:t>branch: feature/meridian-engagement  ·  PR #29  ·  commit: 272787c</a:t>
             </a:r>
           </a:p>
         </p:txBody>

</xml_diff>